<commit_message>
Kit 1: universal lab-exemplar retrofit, both editions
Ms. Rivera follows one artifact through the whole lab: her family
newsletter blurb, from the prompt she types to the beige first draft,
two pushbacks, and the invented schedule detail she catches on the
read-through. Deck slides 21-22 show her chat window large as primary
content in both the member and TpT editions; chips and script
rivera-lines name the same blurb at every step. TpT license,
certificate, and membership framing preserved.

Co-Authored-By: Claude Fable 5 <noreply@anthropic.com>
Claude-Session: https://claude.ai/code/session_019agQ42s1igQaB2X7GGat9R
</commit_message>
<xml_diff>
--- a/kits/kit01-tpt/Kit01_PresentationDeck.pptx
+++ b/kits/kit01-tpt/Kit01_PresentationDeck.pptx
@@ -1587,7 +1587,7 @@
           <a:p>
             <a:r>
               <a:rPr lang="en-US" dirty="0"/>
-              <a:t>Say: this is the moment the session exists for; everything so far was preparation for you actually typing. Nothing has to be good, it's a sandbox, and we practice like we play: zero student information. Announce the tool by name. Energy up; pairs formed inside two minutes.</a:t>
+              <a:t>Say: this is the moment the session exists for; everything so far was preparation for you actually typing. Nothing has to be good, it's a sandbox, and we practice like we play: zero student information. Ms. Rivera builds ONE artifact all the way through this lab on screen: her family newsletter blurb, option A, from typed prompt to reviewed result. Tell the room: if you ever feel lost, copy her structure. Announce the tool by name. Energy up; pairs formed inside two minutes.</a:t>
             </a:r>
             <a:endParaRPr lang="en-US" dirty="0"/>
           </a:p>
@@ -1675,7 +1675,7 @@
           <a:p>
             <a:r>
               <a:rPr lang="en-US" dirty="0"/>
-              <a:t>Circulate. Stuck pairs → option A, it works for every role. Deputize power users to float. Option D comes from a real carpentry classroom; invite electives staff to swap in their station or lab.</a:t>
+              <a:t>Say: pick whichever prompt is closest to your real job, type it, and read what comes back. On screen, Ms. Rivera's window: option A filled in with her fall book fair, and the first draft back. It's beige, and one detail in it will matter in task 2; don't spoil it yet. Circulate. Stuck pairs → option A, it works for every role. Deputize power users to float. Option D comes from a real carpentry classroom; invite electives staff to swap in their station or lab.</a:t>
             </a:r>
             <a:endParaRPr lang="en-US" dirty="0"/>
           </a:p>
@@ -1763,7 +1763,7 @@
           <a:p>
             <a:r>
               <a:rPr lang="en-US" dirty="0"/>
-              <a:t>Say: each of these is a real reply Ms. Rivera types into the chat after the first draft comes back; short and blunt is fine, the tool has no feelings. Push back at least twice on your own draft, the same way. 45-minute version: skip this task, go straight to the debrief. This is the move that separates people who get real value from people who quit in a week.</a:t>
+              <a:t>Say: don't accept the first draft; tell it what's wrong, like you would an intern, short and blunt, the tool has no feelings. On screen, Ms. Rivera's same newsletter blurb after two pushbacks: it finally sounds like her, and her read-through caught the intern inventing "all week, 8:00 to 3:00"; she never typed a schedule. Push back at least twice on your own draft, the same way. 45-minute version: skip this task, go straight to the debrief. This is the move that separates people who get real value from people who quit in a week.</a:t>
             </a:r>
             <a:endParaRPr lang="en-US" dirty="0"/>
           </a:p>
@@ -1851,7 +1851,7 @@
           <a:p>
             <a:r>
               <a:rPr lang="en-US" dirty="0"/>
-              <a:t>If the room saw an AI mistake, spotlight it warmly; it’s the best possible outcome of the lab. Take 3–4 voices, a minute each.</a:t>
+              <a:t>If the room saw an AI mistake, spotlight it warmly; it’s the best possible outcome of the lab. If nobody caught one, point back at Ms. Rivera’s invented book-fair hours from task 2; the read-through is where errors surface. Take 3–4 voices, a minute each.</a:t>
             </a:r>
             <a:endParaRPr lang="en-US" dirty="0"/>
           </a:p>
@@ -12208,7 +12208,7 @@
                 <a:ea typeface="Inter" pitchFamily="34" charset="-122"/>
                 <a:cs typeface="Inter" pitchFamily="34" charset="-120"/>
               </a:rPr>
-              <a:t>Her lab plan: one real task, zero student info, nothing has to be good.</a:t>
+              <a:t>Her lab pick, one artifact all the way through: the family newsletter blurb.</a:t>
             </a:r>
             <a:endParaRPr lang="en-US" sz="1000" dirty="0"/>
           </a:p>
@@ -12989,7 +12989,7 @@
                 <a:ea typeface="Inter" pitchFamily="34" charset="-122"/>
                 <a:cs typeface="Inter" pitchFamily="34" charset="-120"/>
               </a:rPr>
-              <a:t>On her screen: option A, the family newsletter blurb, typed and running.</a:t>
+              <a:t>Her newsletter blurb, v1: option A typed, draft back. Beige, sounds like nobody.</a:t>
             </a:r>
             <a:endParaRPr lang="en-US" sz="1000" dirty="0"/>
           </a:p>
@@ -13043,7 +13043,7 @@
         <p:spPr>
           <a:xfrm>
             <a:off x="548640" y="384048"/>
-            <a:ext cx="11091672" cy="777240"/>
+            <a:ext cx="7955280" cy="777240"/>
           </a:xfrm>
           <a:prstGeom prst="rect">
             <a:avLst/>
@@ -13082,11 +13082,11 @@
         <p:spPr>
           <a:xfrm>
             <a:off x="640080" y="1298448"/>
-            <a:ext cx="10972800" cy="987552"/>
+            <a:ext cx="5074920" cy="1024128"/>
           </a:xfrm>
           <a:prstGeom prst="roundRect">
             <a:avLst>
-              <a:gd name="adj" fmla="val 8333"/>
+              <a:gd name="adj" fmla="val 8036"/>
             </a:avLst>
           </a:prstGeom>
           <a:solidFill>
@@ -13108,8 +13108,8 @@
         </p:nvSpPr>
         <p:spPr>
           <a:xfrm>
-            <a:off x="914400" y="1490472"/>
-            <a:ext cx="603504" cy="603504"/>
+            <a:off x="841248" y="1609344"/>
+            <a:ext cx="402336" cy="402336"/>
           </a:xfrm>
           <a:prstGeom prst="ellipse">
             <a:avLst/>
@@ -13133,8 +13133,8 @@
         </p:nvSpPr>
         <p:spPr>
           <a:xfrm>
-            <a:off x="914400" y="1490472"/>
-            <a:ext cx="603504" cy="603504"/>
+            <a:off x="841248" y="1609344"/>
+            <a:ext cx="402336" cy="402336"/>
           </a:xfrm>
           <a:prstGeom prst="rect">
             <a:avLst/>
@@ -13150,7 +13150,7 @@
               <a:buNone/>
             </a:pPr>
             <a:r>
-              <a:rPr lang="en-US" sz="2100" b="1" dirty="0">
+              <a:rPr lang="en-US" sz="1600" b="1" dirty="0">
                 <a:solidFill>
                   <a:srgbClr val="FFFFFF"/>
                 </a:solidFill>
@@ -13160,7 +13160,7 @@
               </a:rPr>
               <a:t>A</a:t>
             </a:r>
-            <a:endParaRPr lang="en-US" sz="2100" dirty="0"/>
+            <a:endParaRPr lang="en-US" sz="1600" dirty="0"/>
           </a:p>
         </p:txBody>
       </p:sp>
@@ -13172,24 +13172,24 @@
         </p:nvSpPr>
         <p:spPr>
           <a:xfrm>
-            <a:off x="1783080" y="1389888"/>
-            <a:ext cx="3657600" cy="274320"/>
-          </a:xfrm>
-          <a:prstGeom prst="rect">
-            <a:avLst/>
-          </a:prstGeom>
-          <a:noFill/>
-          <a:ln/>
-        </p:spPr>
-        <p:txBody>
-          <a:bodyPr wrap="square" lIns="0" tIns="0" rIns="0" bIns="0" rtlCol="0" anchor="ctr"/>
-          <a:lstStyle/>
-          <a:p>
-            <a:pPr indent="0" marL="0">
-              <a:buNone/>
-            </a:pPr>
-            <a:r>
-              <a:rPr lang="en-US" sz="1100" b="1" spc="150" kern="0" dirty="0">
+            <a:off x="1389888" y="1380744"/>
+            <a:ext cx="4206240" cy="237744"/>
+          </a:xfrm>
+          <a:prstGeom prst="rect">
+            <a:avLst/>
+          </a:prstGeom>
+          <a:noFill/>
+          <a:ln/>
+        </p:spPr>
+        <p:txBody>
+          <a:bodyPr wrap="square" lIns="0" tIns="0" rIns="0" bIns="0" rtlCol="0" anchor="ctr"/>
+          <a:lstStyle/>
+          <a:p>
+            <a:pPr indent="0" marL="0">
+              <a:buNone/>
+            </a:pPr>
+            <a:r>
+              <a:rPr lang="en-US" sz="950" b="1" spc="150" kern="0" dirty="0">
                 <a:solidFill>
                   <a:srgbClr val="2A9D8F"/>
                 </a:solidFill>
@@ -13199,7 +13199,7 @@
               </a:rPr>
               <a:t>FAMILIES</a:t>
             </a:r>
-            <a:endParaRPr lang="en-US" sz="1100" dirty="0"/>
+            <a:endParaRPr lang="en-US" sz="950" dirty="0"/>
           </a:p>
         </p:txBody>
       </p:sp>
@@ -13211,8 +13211,8 @@
         </p:nvSpPr>
         <p:spPr>
           <a:xfrm>
-            <a:off x="1783080" y="1645920"/>
-            <a:ext cx="9509760" cy="603504"/>
+            <a:off x="1389888" y="1618488"/>
+            <a:ext cx="4224528" cy="658368"/>
           </a:xfrm>
           <a:prstGeom prst="rect">
             <a:avLst/>
@@ -13228,7 +13228,7 @@
               <a:buNone/>
             </a:pPr>
             <a:r>
-              <a:rPr lang="en-US" sz="1450" dirty="0">
+              <a:rPr lang="en-US" sz="1200" dirty="0">
                 <a:solidFill>
                   <a:srgbClr val="1B1F24"/>
                 </a:solidFill>
@@ -13238,7 +13238,7 @@
               </a:rPr>
               <a:t>“Write a warm, professional newsletter blurb for families about [any upcoming school event], under 120 words.”</a:t>
             </a:r>
-            <a:endParaRPr lang="en-US" sz="1450" dirty="0"/>
+            <a:endParaRPr lang="en-US" sz="1200" dirty="0"/>
           </a:p>
         </p:txBody>
       </p:sp>
@@ -13250,12 +13250,12 @@
         </p:nvSpPr>
         <p:spPr>
           <a:xfrm>
-            <a:off x="640080" y="2414016"/>
-            <a:ext cx="10972800" cy="987552"/>
+            <a:off x="640080" y="2395728"/>
+            <a:ext cx="5074920" cy="1024128"/>
           </a:xfrm>
           <a:prstGeom prst="roundRect">
             <a:avLst>
-              <a:gd name="adj" fmla="val 8333"/>
+              <a:gd name="adj" fmla="val 8036"/>
             </a:avLst>
           </a:prstGeom>
           <a:solidFill>
@@ -13277,8 +13277,8 @@
         </p:nvSpPr>
         <p:spPr>
           <a:xfrm>
-            <a:off x="914400" y="2606040"/>
-            <a:ext cx="603504" cy="603504"/>
+            <a:off x="841248" y="2706624"/>
+            <a:ext cx="402336" cy="402336"/>
           </a:xfrm>
           <a:prstGeom prst="ellipse">
             <a:avLst/>
@@ -13302,8 +13302,8 @@
         </p:nvSpPr>
         <p:spPr>
           <a:xfrm>
-            <a:off x="914400" y="2606040"/>
-            <a:ext cx="603504" cy="603504"/>
+            <a:off x="841248" y="2706624"/>
+            <a:ext cx="402336" cy="402336"/>
           </a:xfrm>
           <a:prstGeom prst="rect">
             <a:avLst/>
@@ -13319,7 +13319,7 @@
               <a:buNone/>
             </a:pPr>
             <a:r>
-              <a:rPr lang="en-US" sz="2100" b="1" dirty="0">
+              <a:rPr lang="en-US" sz="1600" b="1" dirty="0">
                 <a:solidFill>
                   <a:srgbClr val="FFFFFF"/>
                 </a:solidFill>
@@ -13329,7 +13329,7 @@
               </a:rPr>
               <a:t>B</a:t>
             </a:r>
-            <a:endParaRPr lang="en-US" sz="2100" dirty="0"/>
+            <a:endParaRPr lang="en-US" sz="1600" dirty="0"/>
           </a:p>
         </p:txBody>
       </p:sp>
@@ -13341,24 +13341,24 @@
         </p:nvSpPr>
         <p:spPr>
           <a:xfrm>
-            <a:off x="1783080" y="2505456"/>
-            <a:ext cx="3657600" cy="274320"/>
-          </a:xfrm>
-          <a:prstGeom prst="rect">
-            <a:avLst/>
-          </a:prstGeom>
-          <a:noFill/>
-          <a:ln/>
-        </p:spPr>
-        <p:txBody>
-          <a:bodyPr wrap="square" lIns="0" tIns="0" rIns="0" bIns="0" rtlCol="0" anchor="ctr"/>
-          <a:lstStyle/>
-          <a:p>
-            <a:pPr indent="0" marL="0">
-              <a:buNone/>
-            </a:pPr>
-            <a:r>
-              <a:rPr lang="en-US" sz="1100" b="1" spc="150" kern="0" dirty="0">
+            <a:off x="1389888" y="2478024"/>
+            <a:ext cx="4206240" cy="237744"/>
+          </a:xfrm>
+          <a:prstGeom prst="rect">
+            <a:avLst/>
+          </a:prstGeom>
+          <a:noFill/>
+          <a:ln/>
+        </p:spPr>
+        <p:txBody>
+          <a:bodyPr wrap="square" lIns="0" tIns="0" rIns="0" bIns="0" rtlCol="0" anchor="ctr"/>
+          <a:lstStyle/>
+          <a:p>
+            <a:pPr indent="0" marL="0">
+              <a:buNone/>
+            </a:pPr>
+            <a:r>
+              <a:rPr lang="en-US" sz="950" b="1" spc="150" kern="0" dirty="0">
                 <a:solidFill>
                   <a:srgbClr val="2A9D8F"/>
                 </a:solidFill>
@@ -13368,7 +13368,7 @@
               </a:rPr>
               <a:t>ASSESSMENT</a:t>
             </a:r>
-            <a:endParaRPr lang="en-US" sz="1100" dirty="0"/>
+            <a:endParaRPr lang="en-US" sz="950" dirty="0"/>
           </a:p>
         </p:txBody>
       </p:sp>
@@ -13380,8 +13380,8 @@
         </p:nvSpPr>
         <p:spPr>
           <a:xfrm>
-            <a:off x="1783080" y="2761488"/>
-            <a:ext cx="9509760" cy="603504"/>
+            <a:off x="1389888" y="2715768"/>
+            <a:ext cx="4224528" cy="658368"/>
           </a:xfrm>
           <a:prstGeom prst="rect">
             <a:avLst/>
@@ -13397,7 +13397,7 @@
               <a:buNone/>
             </a:pPr>
             <a:r>
-              <a:rPr lang="en-US" sz="1450" dirty="0">
+              <a:rPr lang="en-US" sz="1200" dirty="0">
                 <a:solidFill>
                   <a:srgbClr val="1B1F24"/>
                 </a:solidFill>
@@ -13407,7 +13407,7 @@
               </a:rPr>
               <a:t>“Create a five-question review quiz on [any topic you teach], mixed difficulty, with an answer key.”</a:t>
             </a:r>
-            <a:endParaRPr lang="en-US" sz="1450" dirty="0"/>
+            <a:endParaRPr lang="en-US" sz="1200" dirty="0"/>
           </a:p>
         </p:txBody>
       </p:sp>
@@ -13419,12 +13419,12 @@
         </p:nvSpPr>
         <p:spPr>
           <a:xfrm>
-            <a:off x="640080" y="3529584"/>
-            <a:ext cx="10972800" cy="987552"/>
+            <a:off x="640080" y="3493008"/>
+            <a:ext cx="5074920" cy="1024128"/>
           </a:xfrm>
           <a:prstGeom prst="roundRect">
             <a:avLst>
-              <a:gd name="adj" fmla="val 8333"/>
+              <a:gd name="adj" fmla="val 8036"/>
             </a:avLst>
           </a:prstGeom>
           <a:solidFill>
@@ -13446,8 +13446,8 @@
         </p:nvSpPr>
         <p:spPr>
           <a:xfrm>
-            <a:off x="914400" y="3721608"/>
-            <a:ext cx="603504" cy="603504"/>
+            <a:off x="841248" y="3803904"/>
+            <a:ext cx="402336" cy="402336"/>
           </a:xfrm>
           <a:prstGeom prst="ellipse">
             <a:avLst/>
@@ -13471,8 +13471,8 @@
         </p:nvSpPr>
         <p:spPr>
           <a:xfrm>
-            <a:off x="914400" y="3721608"/>
-            <a:ext cx="603504" cy="603504"/>
+            <a:off x="841248" y="3803904"/>
+            <a:ext cx="402336" cy="402336"/>
           </a:xfrm>
           <a:prstGeom prst="rect">
             <a:avLst/>
@@ -13488,7 +13488,7 @@
               <a:buNone/>
             </a:pPr>
             <a:r>
-              <a:rPr lang="en-US" sz="2100" b="1" dirty="0">
+              <a:rPr lang="en-US" sz="1600" b="1" dirty="0">
                 <a:solidFill>
                   <a:srgbClr val="FFFFFF"/>
                 </a:solidFill>
@@ -13498,7 +13498,7 @@
               </a:rPr>
               <a:t>C</a:t>
             </a:r>
-            <a:endParaRPr lang="en-US" sz="2100" dirty="0"/>
+            <a:endParaRPr lang="en-US" sz="1600" dirty="0"/>
           </a:p>
         </p:txBody>
       </p:sp>
@@ -13510,24 +13510,24 @@
         </p:nvSpPr>
         <p:spPr>
           <a:xfrm>
-            <a:off x="1783080" y="3621024"/>
-            <a:ext cx="3657600" cy="274320"/>
-          </a:xfrm>
-          <a:prstGeom prst="rect">
-            <a:avLst/>
-          </a:prstGeom>
-          <a:noFill/>
-          <a:ln/>
-        </p:spPr>
-        <p:txBody>
-          <a:bodyPr wrap="square" lIns="0" tIns="0" rIns="0" bIns="0" rtlCol="0" anchor="ctr"/>
-          <a:lstStyle/>
-          <a:p>
-            <a:pPr indent="0" marL="0">
-              <a:buNone/>
-            </a:pPr>
-            <a:r>
-              <a:rPr lang="en-US" sz="1100" b="1" spc="150" kern="0" dirty="0">
+            <a:off x="1389888" y="3575304"/>
+            <a:ext cx="4206240" cy="237744"/>
+          </a:xfrm>
+          <a:prstGeom prst="rect">
+            <a:avLst/>
+          </a:prstGeom>
+          <a:noFill/>
+          <a:ln/>
+        </p:spPr>
+        <p:txBody>
+          <a:bodyPr wrap="square" lIns="0" tIns="0" rIns="0" bIns="0" rtlCol="0" anchor="ctr"/>
+          <a:lstStyle/>
+          <a:p>
+            <a:pPr indent="0" marL="0">
+              <a:buNone/>
+            </a:pPr>
+            <a:r>
+              <a:rPr lang="en-US" sz="950" b="1" spc="150" kern="0" dirty="0">
                 <a:solidFill>
                   <a:srgbClr val="2A9D8F"/>
                 </a:solidFill>
@@ -13537,7 +13537,7 @@
               </a:rPr>
               <a:t>DIFFERENTIATION</a:t>
             </a:r>
-            <a:endParaRPr lang="en-US" sz="1100" dirty="0"/>
+            <a:endParaRPr lang="en-US" sz="950" dirty="0"/>
           </a:p>
         </p:txBody>
       </p:sp>
@@ -13549,8 +13549,8 @@
         </p:nvSpPr>
         <p:spPr>
           <a:xfrm>
-            <a:off x="1783080" y="3877056"/>
-            <a:ext cx="9509760" cy="603504"/>
+            <a:off x="1389888" y="3813048"/>
+            <a:ext cx="4224528" cy="658368"/>
           </a:xfrm>
           <a:prstGeom prst="rect">
             <a:avLst/>
@@ -13566,7 +13566,7 @@
               <a:buNone/>
             </a:pPr>
             <a:r>
-              <a:rPr lang="en-US" sz="1450" dirty="0">
+              <a:rPr lang="en-US" sz="1200" dirty="0">
                 <a:solidFill>
                   <a:srgbClr val="1B1F24"/>
                 </a:solidFill>
@@ -13576,7 +13576,7 @@
               </a:rPr>
               <a:t>“Rewrite this paragraph at three different reading levels.” Then paste any paragraph you already have.</a:t>
             </a:r>
-            <a:endParaRPr lang="en-US" sz="1450" dirty="0"/>
+            <a:endParaRPr lang="en-US" sz="1200" dirty="0"/>
           </a:p>
         </p:txBody>
       </p:sp>
@@ -13588,12 +13588,12 @@
         </p:nvSpPr>
         <p:spPr>
           <a:xfrm>
-            <a:off x="640080" y="4645152"/>
-            <a:ext cx="10972800" cy="987552"/>
+            <a:off x="640080" y="4590288"/>
+            <a:ext cx="5074920" cy="1024128"/>
           </a:xfrm>
           <a:prstGeom prst="roundRect">
             <a:avLst>
-              <a:gd name="adj" fmla="val 8333"/>
+              <a:gd name="adj" fmla="val 8036"/>
             </a:avLst>
           </a:prstGeom>
           <a:solidFill>
@@ -13615,8 +13615,8 @@
         </p:nvSpPr>
         <p:spPr>
           <a:xfrm>
-            <a:off x="914400" y="4837176"/>
-            <a:ext cx="603504" cy="603504"/>
+            <a:off x="841248" y="4901184"/>
+            <a:ext cx="402336" cy="402336"/>
           </a:xfrm>
           <a:prstGeom prst="ellipse">
             <a:avLst/>
@@ -13640,8 +13640,8 @@
         </p:nvSpPr>
         <p:spPr>
           <a:xfrm>
-            <a:off x="914400" y="4837176"/>
-            <a:ext cx="603504" cy="603504"/>
+            <a:off x="841248" y="4901184"/>
+            <a:ext cx="402336" cy="402336"/>
           </a:xfrm>
           <a:prstGeom prst="rect">
             <a:avLst/>
@@ -13657,7 +13657,7 @@
               <a:buNone/>
             </a:pPr>
             <a:r>
-              <a:rPr lang="en-US" sz="2100" b="1" dirty="0">
+              <a:rPr lang="en-US" sz="1600" b="1" dirty="0">
                 <a:solidFill>
                   <a:srgbClr val="FFFFFF"/>
                 </a:solidFill>
@@ -13667,7 +13667,7 @@
               </a:rPr>
               <a:t>D</a:t>
             </a:r>
-            <a:endParaRPr lang="en-US" sz="2100" dirty="0"/>
+            <a:endParaRPr lang="en-US" sz="1600" dirty="0"/>
           </a:p>
         </p:txBody>
       </p:sp>
@@ -13679,24 +13679,24 @@
         </p:nvSpPr>
         <p:spPr>
           <a:xfrm>
-            <a:off x="1783080" y="4736592"/>
-            <a:ext cx="3657600" cy="274320"/>
-          </a:xfrm>
-          <a:prstGeom prst="rect">
-            <a:avLst/>
-          </a:prstGeom>
-          <a:noFill/>
-          <a:ln/>
-        </p:spPr>
-        <p:txBody>
-          <a:bodyPr wrap="square" lIns="0" tIns="0" rIns="0" bIns="0" rtlCol="0" anchor="ctr"/>
-          <a:lstStyle/>
-          <a:p>
-            <a:pPr indent="0" marL="0">
-              <a:buNone/>
-            </a:pPr>
-            <a:r>
-              <a:rPr lang="en-US" sz="1100" b="1" spc="150" kern="0" dirty="0">
+            <a:off x="1389888" y="4672584"/>
+            <a:ext cx="4206240" cy="237744"/>
+          </a:xfrm>
+          <a:prstGeom prst="rect">
+            <a:avLst/>
+          </a:prstGeom>
+          <a:noFill/>
+          <a:ln/>
+        </p:spPr>
+        <p:txBody>
+          <a:bodyPr wrap="square" lIns="0" tIns="0" rIns="0" bIns="0" rtlCol="0" anchor="ctr"/>
+          <a:lstStyle/>
+          <a:p>
+            <a:pPr indent="0" marL="0">
+              <a:buNone/>
+            </a:pPr>
+            <a:r>
+              <a:rPr lang="en-US" sz="950" b="1" spc="150" kern="0" dirty="0">
                 <a:solidFill>
                   <a:srgbClr val="2A9D8F"/>
                 </a:solidFill>
@@ -13706,20 +13706,266 @@
               </a:rPr>
               <a:t>CTE &amp; ELECTIVES</a:t>
             </a:r>
+            <a:endParaRPr lang="en-US" sz="950" dirty="0"/>
+          </a:p>
+        </p:txBody>
+      </p:sp>
+      <p:sp>
+        <p:nvSpPr>
+          <p:cNvPr id="33" name="Text 30"/>
+          <p:cNvSpPr/>
+          <p:nvPr/>
+        </p:nvSpPr>
+        <p:spPr>
+          <a:xfrm>
+            <a:off x="1389888" y="4910328"/>
+            <a:ext cx="4224528" cy="658368"/>
+          </a:xfrm>
+          <a:prstGeom prst="rect">
+            <a:avLst/>
+          </a:prstGeom>
+          <a:noFill/>
+          <a:ln/>
+        </p:spPr>
+        <p:txBody>
+          <a:bodyPr wrap="square" lIns="0" tIns="0" rIns="0" bIns="0" rtlCol="0" anchor="t"/>
+          <a:lstStyle/>
+          <a:p>
+            <a:pPr indent="0" marL="0">
+              <a:buNone/>
+            </a:pPr>
+            <a:r>
+              <a:rPr lang="en-US" sz="1200" dirty="0">
+                <a:solidFill>
+                  <a:srgbClr val="1B1F24"/>
+                </a:solidFill>
+                <a:latin typeface="Inter" pitchFamily="34" charset="0"/>
+                <a:ea typeface="Inter" pitchFamily="34" charset="-122"/>
+                <a:cs typeface="Inter" pitchFamily="34" charset="-120"/>
+              </a:rPr>
+              <a:t>“Create a five-question tool safety check for the miter saw station, mixed question formats, with an answer key.” Swap in any station, lab, kitchen, or instrument.</a:t>
+            </a:r>
+            <a:endParaRPr lang="en-US" sz="1200" dirty="0"/>
+          </a:p>
+        </p:txBody>
+      </p:sp>
+      <p:sp>
+        <p:nvSpPr>
+          <p:cNvPr id="34" name="Shape 31"/>
+          <p:cNvSpPr/>
+          <p:nvPr/>
+        </p:nvSpPr>
+        <p:spPr>
+          <a:xfrm>
+            <a:off x="5897880" y="1298448"/>
+            <a:ext cx="5715000" cy="4315968"/>
+          </a:xfrm>
+          <a:prstGeom prst="roundRect">
+            <a:avLst>
+              <a:gd name="adj" fmla="val 2119"/>
+            </a:avLst>
+          </a:prstGeom>
+          <a:solidFill>
+            <a:srgbClr val="FFFFFF"/>
+          </a:solidFill>
+          <a:ln w="19050">
+            <a:solidFill>
+              <a:srgbClr val="DCE3EA"/>
+            </a:solidFill>
+            <a:prstDash val="solid"/>
+          </a:ln>
+        </p:spPr>
+      </p:sp>
+      <p:sp>
+        <p:nvSpPr>
+          <p:cNvPr id="35" name="Shape 32"/>
+          <p:cNvSpPr/>
+          <p:nvPr/>
+        </p:nvSpPr>
+        <p:spPr>
+          <a:xfrm>
+            <a:off x="5897880" y="1298448"/>
+            <a:ext cx="5715000" cy="384048"/>
+          </a:xfrm>
+          <a:prstGeom prst="roundRect">
+            <a:avLst>
+              <a:gd name="adj" fmla="val 23810"/>
+            </a:avLst>
+          </a:prstGeom>
+          <a:solidFill>
+            <a:srgbClr val="13293D"/>
+          </a:solidFill>
+          <a:ln w="12700">
+            <a:solidFill>
+              <a:srgbClr val="13293D"/>
+            </a:solidFill>
+            <a:prstDash val="solid"/>
+          </a:ln>
+        </p:spPr>
+      </p:sp>
+      <p:sp>
+        <p:nvSpPr>
+          <p:cNvPr id="36" name="Shape 33"/>
+          <p:cNvSpPr/>
+          <p:nvPr/>
+        </p:nvSpPr>
+        <p:spPr>
+          <a:xfrm>
+            <a:off x="6099048" y="1417320"/>
+            <a:ext cx="146304" cy="146304"/>
+          </a:xfrm>
+          <a:prstGeom prst="ellipse">
+            <a:avLst/>
+          </a:prstGeom>
+          <a:solidFill>
+            <a:srgbClr val="E8837A"/>
+          </a:solidFill>
+          <a:ln w="12700">
+            <a:solidFill>
+              <a:srgbClr val="E8837A"/>
+            </a:solidFill>
+            <a:prstDash val="solid"/>
+          </a:ln>
+        </p:spPr>
+      </p:sp>
+      <p:sp>
+        <p:nvSpPr>
+          <p:cNvPr id="37" name="Shape 34"/>
+          <p:cNvSpPr/>
+          <p:nvPr/>
+        </p:nvSpPr>
+        <p:spPr>
+          <a:xfrm>
+            <a:off x="6345936" y="1417320"/>
+            <a:ext cx="146304" cy="146304"/>
+          </a:xfrm>
+          <a:prstGeom prst="ellipse">
+            <a:avLst/>
+          </a:prstGeom>
+          <a:solidFill>
+            <a:srgbClr val="F4A825"/>
+          </a:solidFill>
+          <a:ln w="12700">
+            <a:solidFill>
+              <a:srgbClr val="F4A825"/>
+            </a:solidFill>
+            <a:prstDash val="solid"/>
+          </a:ln>
+        </p:spPr>
+      </p:sp>
+      <p:sp>
+        <p:nvSpPr>
+          <p:cNvPr id="38" name="Shape 35"/>
+          <p:cNvSpPr/>
+          <p:nvPr/>
+        </p:nvSpPr>
+        <p:spPr>
+          <a:xfrm>
+            <a:off x="6592824" y="1417320"/>
+            <a:ext cx="146304" cy="146304"/>
+          </a:xfrm>
+          <a:prstGeom prst="ellipse">
+            <a:avLst/>
+          </a:prstGeom>
+          <a:solidFill>
+            <a:srgbClr val="2E7D5B"/>
+          </a:solidFill>
+          <a:ln w="12700">
+            <a:solidFill>
+              <a:srgbClr val="2E7D5B"/>
+            </a:solidFill>
+            <a:prstDash val="solid"/>
+          </a:ln>
+        </p:spPr>
+      </p:sp>
+      <p:sp>
+        <p:nvSpPr>
+          <p:cNvPr id="39" name="Text 36"/>
+          <p:cNvSpPr/>
+          <p:nvPr/>
+        </p:nvSpPr>
+        <p:spPr>
+          <a:xfrm>
+            <a:off x="6949440" y="1298448"/>
+            <a:ext cx="4526280" cy="384048"/>
+          </a:xfrm>
+          <a:prstGeom prst="rect">
+            <a:avLst/>
+          </a:prstGeom>
+          <a:noFill/>
+          <a:ln/>
+        </p:spPr>
+        <p:txBody>
+          <a:bodyPr wrap="square" lIns="0" tIns="0" rIns="0" bIns="0" rtlCol="0" anchor="ctr"/>
+          <a:lstStyle/>
+          <a:p>
+            <a:pPr indent="0" marL="0">
+              <a:buNone/>
+            </a:pPr>
+            <a:r>
+              <a:rPr lang="en-US" sz="1100" dirty="0">
+                <a:solidFill>
+                  <a:srgbClr val="9FB2C2"/>
+                </a:solidFill>
+                <a:latin typeface="Inter" pitchFamily="34" charset="0"/>
+                <a:ea typeface="Inter" pitchFamily="34" charset="-122"/>
+                <a:cs typeface="Inter" pitchFamily="34" charset="-120"/>
+              </a:rPr>
+              <a:t>Ms. Rivera’s newsletter blurb · task 1 · option A, typed</a:t>
+            </a:r>
             <a:endParaRPr lang="en-US" sz="1100" dirty="0"/>
           </a:p>
         </p:txBody>
       </p:sp>
       <p:sp>
         <p:nvSpPr>
-          <p:cNvPr id="33" name="Text 30"/>
-          <p:cNvSpPr/>
-          <p:nvPr/>
-        </p:nvSpPr>
-        <p:spPr>
-          <a:xfrm>
-            <a:off x="1783080" y="4992624"/>
-            <a:ext cx="9509760" cy="603504"/>
+          <p:cNvPr id="40" name="Text 37"/>
+          <p:cNvSpPr/>
+          <p:nvPr/>
+        </p:nvSpPr>
+        <p:spPr>
+          <a:xfrm>
+            <a:off x="6172200" y="1810512"/>
+            <a:ext cx="5166360" cy="256032"/>
+          </a:xfrm>
+          <a:prstGeom prst="rect">
+            <a:avLst/>
+          </a:prstGeom>
+          <a:noFill/>
+          <a:ln/>
+        </p:spPr>
+        <p:txBody>
+          <a:bodyPr wrap="square" lIns="0" tIns="0" rIns="0" bIns="0" rtlCol="0" anchor="ctr"/>
+          <a:lstStyle/>
+          <a:p>
+            <a:pPr indent="0" marL="0">
+              <a:buNone/>
+            </a:pPr>
+            <a:r>
+              <a:rPr lang="en-US" sz="1000" b="1" spc="150" kern="0" dirty="0">
+                <a:solidFill>
+                  <a:srgbClr val="2A9D8F"/>
+                </a:solidFill>
+                <a:latin typeface="Inter" pitchFamily="34" charset="0"/>
+                <a:ea typeface="Inter" pitchFamily="34" charset="-122"/>
+                <a:cs typeface="Inter" pitchFamily="34" charset="-120"/>
+              </a:rPr>
+              <a:t>SHE TYPES · OPTION A, FILLED IN</a:t>
+            </a:r>
+            <a:endParaRPr lang="en-US" sz="1000" dirty="0"/>
+          </a:p>
+        </p:txBody>
+      </p:sp>
+      <p:sp>
+        <p:nvSpPr>
+          <p:cNvPr id="41" name="Text 38"/>
+          <p:cNvSpPr/>
+          <p:nvPr/>
+        </p:nvSpPr>
+        <p:spPr>
+          <a:xfrm>
+            <a:off x="6172200" y="2084832"/>
+            <a:ext cx="5166360" cy="777240"/>
           </a:xfrm>
           <a:prstGeom prst="rect">
             <a:avLst/>
@@ -13732,10 +13978,94 @@
           <a:lstStyle/>
           <a:p>
             <a:pPr indent="0" marL="0">
-              <a:buNone/>
-            </a:pPr>
-            <a:r>
-              <a:rPr lang="en-US" sz="1450" dirty="0">
+              <a:lnSpc>
+                <a:spcPct val="112000"/>
+              </a:lnSpc>
+              <a:buNone/>
+            </a:pPr>
+            <a:r>
+              <a:rPr lang="en-US" sz="1450" i="1" dirty="0">
+                <a:solidFill>
+                  <a:srgbClr val="13293D"/>
+                </a:solidFill>
+                <a:latin typeface="Inter" pitchFamily="34" charset="0"/>
+                <a:ea typeface="Inter" pitchFamily="34" charset="-122"/>
+                <a:cs typeface="Inter" pitchFamily="34" charset="-120"/>
+              </a:rPr>
+              <a:t>“Write a warm, professional newsletter blurb for families about our fall book fair, under 120 words.”</a:t>
+            </a:r>
+            <a:endParaRPr lang="en-US" sz="1450" dirty="0"/>
+          </a:p>
+        </p:txBody>
+      </p:sp>
+      <p:sp>
+        <p:nvSpPr>
+          <p:cNvPr id="42" name="Text 39"/>
+          <p:cNvSpPr/>
+          <p:nvPr/>
+        </p:nvSpPr>
+        <p:spPr>
+          <a:xfrm>
+            <a:off x="6172200" y="3017520"/>
+            <a:ext cx="5166360" cy="256032"/>
+          </a:xfrm>
+          <a:prstGeom prst="rect">
+            <a:avLst/>
+          </a:prstGeom>
+          <a:noFill/>
+          <a:ln/>
+        </p:spPr>
+        <p:txBody>
+          <a:bodyPr wrap="square" lIns="0" tIns="0" rIns="0" bIns="0" rtlCol="0" anchor="ctr"/>
+          <a:lstStyle/>
+          <a:p>
+            <a:pPr indent="0" marL="0">
+              <a:buNone/>
+            </a:pPr>
+            <a:r>
+              <a:rPr lang="en-US" sz="1000" b="1" spc="150" kern="0" dirty="0">
+                <a:solidFill>
+                  <a:srgbClr val="5B6B7A"/>
+                </a:solidFill>
+                <a:latin typeface="Inter" pitchFamily="34" charset="0"/>
+                <a:ea typeface="Inter" pitchFamily="34" charset="-122"/>
+                <a:cs typeface="Inter" pitchFamily="34" charset="-120"/>
+              </a:rPr>
+              <a:t>THE FIRST DRAFT COMES BACK</a:t>
+            </a:r>
+            <a:endParaRPr lang="en-US" sz="1000" dirty="0"/>
+          </a:p>
+        </p:txBody>
+      </p:sp>
+      <p:sp>
+        <p:nvSpPr>
+          <p:cNvPr id="43" name="Text 40"/>
+          <p:cNvSpPr/>
+          <p:nvPr/>
+        </p:nvSpPr>
+        <p:spPr>
+          <a:xfrm>
+            <a:off x="6172200" y="3291840"/>
+            <a:ext cx="5166360" cy="1417320"/>
+          </a:xfrm>
+          <a:prstGeom prst="rect">
+            <a:avLst/>
+          </a:prstGeom>
+          <a:noFill/>
+          <a:ln/>
+        </p:spPr>
+        <p:txBody>
+          <a:bodyPr wrap="square" lIns="0" tIns="0" rIns="0" bIns="0" rtlCol="0" anchor="t"/>
+          <a:lstStyle/>
+          <a:p>
+            <a:pPr indent="0" marL="0">
+              <a:lnSpc>
+                <a:spcPct val="112000"/>
+              </a:lnSpc>
+              <a:buNone/>
+            </a:pPr>
+            <a:r>
+              <a:rPr lang="en-US" sz="1400" dirty="0">
                 <a:solidFill>
                   <a:srgbClr val="1B1F24"/>
                 </a:solidFill>
@@ -13743,15 +14073,54 @@
                 <a:ea typeface="Inter" pitchFamily="34" charset="-122"/>
                 <a:cs typeface="Inter" pitchFamily="34" charset="-120"/>
               </a:rPr>
-              <a:t>“Create a five-question tool safety check for the miter saw station, mixed question formats, with an answer key.” Swap in any station, lab, kitchen, or instrument.</a:t>
-            </a:r>
-            <a:endParaRPr lang="en-US" sz="1450" dirty="0"/>
-          </a:p>
-        </p:txBody>
-      </p:sp>
-      <p:sp>
-        <p:nvSpPr>
-          <p:cNvPr id="34" name="Text 31"/>
+              <a:t>“Dear families, we are thrilled to announce our upcoming Book Fair! This wonderful event promises something for every reader. The fair runs all week, 8:00 to 3:00. We sincerely appreciate your continued support!”</a:t>
+            </a:r>
+            <a:endParaRPr lang="en-US" sz="1400" dirty="0"/>
+          </a:p>
+        </p:txBody>
+      </p:sp>
+      <p:sp>
+        <p:nvSpPr>
+          <p:cNvPr id="44" name="Text 41"/>
+          <p:cNvSpPr/>
+          <p:nvPr/>
+        </p:nvSpPr>
+        <p:spPr>
+          <a:xfrm>
+            <a:off x="6172200" y="4937760"/>
+            <a:ext cx="5166360" cy="548640"/>
+          </a:xfrm>
+          <a:prstGeom prst="rect">
+            <a:avLst/>
+          </a:prstGeom>
+          <a:noFill/>
+          <a:ln/>
+        </p:spPr>
+        <p:txBody>
+          <a:bodyPr wrap="square" lIns="0" tIns="0" rIns="0" bIns="0" rtlCol="0" anchor="t"/>
+          <a:lstStyle/>
+          <a:p>
+            <a:pPr indent="0" marL="0">
+              <a:buNone/>
+            </a:pPr>
+            <a:r>
+              <a:rPr lang="en-US" sz="1150" i="1" dirty="0">
+                <a:solidFill>
+                  <a:srgbClr val="5B6B7A"/>
+                </a:solidFill>
+                <a:latin typeface="Inter" pitchFamily="34" charset="0"/>
+                <a:ea typeface="Inter" pitchFamily="34" charset="-122"/>
+                <a:cs typeface="Inter" pitchFamily="34" charset="-120"/>
+              </a:rPr>
+              <a:t>Beige, and it sounds like nobody. Keep yours on screen; task 2 works on this exact draft.</a:t>
+            </a:r>
+            <a:endParaRPr lang="en-US" sz="1150" dirty="0"/>
+          </a:p>
+        </p:txBody>
+      </p:sp>
+      <p:sp>
+        <p:nvSpPr>
+          <p:cNvPr id="45" name="Text 42"/>
           <p:cNvSpPr/>
           <p:nvPr/>
         </p:nvSpPr>
@@ -13938,7 +14307,214 @@
       </p:sp>
       <p:sp>
         <p:nvSpPr>
-          <p:cNvPr id="5" name="Text 2"/>
+          <p:cNvPr id="5" name="Shape 2"/>
+          <p:cNvSpPr/>
+          <p:nvPr/>
+        </p:nvSpPr>
+        <p:spPr>
+          <a:xfrm>
+            <a:off x="8732520" y="109728"/>
+            <a:ext cx="2926080" cy="896112"/>
+          </a:xfrm>
+          <a:prstGeom prst="roundRect">
+            <a:avLst>
+              <a:gd name="adj" fmla="val 7143"/>
+            </a:avLst>
+          </a:prstGeom>
+          <a:solidFill>
+            <a:srgbClr val="F7F5F0"/>
+          </a:solidFill>
+          <a:ln w="12700">
+            <a:solidFill>
+              <a:srgbClr val="DCE3EA"/>
+            </a:solidFill>
+            <a:prstDash val="solid"/>
+          </a:ln>
+        </p:spPr>
+      </p:sp>
+      <p:sp>
+        <p:nvSpPr>
+          <p:cNvPr id="6" name="Shape 3"/>
+          <p:cNvSpPr/>
+          <p:nvPr/>
+        </p:nvSpPr>
+        <p:spPr>
+          <a:xfrm>
+            <a:off x="8732520" y="109728"/>
+            <a:ext cx="2926080" cy="237744"/>
+          </a:xfrm>
+          <a:prstGeom prst="roundRect">
+            <a:avLst>
+              <a:gd name="adj" fmla="val 26923"/>
+            </a:avLst>
+          </a:prstGeom>
+          <a:solidFill>
+            <a:srgbClr val="0D1E2E"/>
+          </a:solidFill>
+          <a:ln w="12700">
+            <a:solidFill>
+              <a:srgbClr val="0D1E2E"/>
+            </a:solidFill>
+            <a:prstDash val="solid"/>
+          </a:ln>
+        </p:spPr>
+      </p:sp>
+      <p:sp>
+        <p:nvSpPr>
+          <p:cNvPr id="7" name="Shape 4"/>
+          <p:cNvSpPr/>
+          <p:nvPr/>
+        </p:nvSpPr>
+        <p:spPr>
+          <a:xfrm>
+            <a:off x="8823960" y="182880"/>
+            <a:ext cx="91440" cy="91440"/>
+          </a:xfrm>
+          <a:prstGeom prst="ellipse">
+            <a:avLst/>
+          </a:prstGeom>
+          <a:solidFill>
+            <a:srgbClr val="E8837A"/>
+          </a:solidFill>
+          <a:ln w="12700">
+            <a:solidFill>
+              <a:srgbClr val="E8837A"/>
+            </a:solidFill>
+            <a:prstDash val="solid"/>
+          </a:ln>
+        </p:spPr>
+      </p:sp>
+      <p:sp>
+        <p:nvSpPr>
+          <p:cNvPr id="8" name="Shape 5"/>
+          <p:cNvSpPr/>
+          <p:nvPr/>
+        </p:nvSpPr>
+        <p:spPr>
+          <a:xfrm>
+            <a:off x="8970264" y="182880"/>
+            <a:ext cx="91440" cy="91440"/>
+          </a:xfrm>
+          <a:prstGeom prst="ellipse">
+            <a:avLst/>
+          </a:prstGeom>
+          <a:solidFill>
+            <a:srgbClr val="F4A825"/>
+          </a:solidFill>
+          <a:ln w="12700">
+            <a:solidFill>
+              <a:srgbClr val="F4A825"/>
+            </a:solidFill>
+            <a:prstDash val="solid"/>
+          </a:ln>
+        </p:spPr>
+      </p:sp>
+      <p:sp>
+        <p:nvSpPr>
+          <p:cNvPr id="9" name="Shape 6"/>
+          <p:cNvSpPr/>
+          <p:nvPr/>
+        </p:nvSpPr>
+        <p:spPr>
+          <a:xfrm>
+            <a:off x="9116568" y="182880"/>
+            <a:ext cx="91440" cy="91440"/>
+          </a:xfrm>
+          <a:prstGeom prst="ellipse">
+            <a:avLst/>
+          </a:prstGeom>
+          <a:solidFill>
+            <a:srgbClr val="2E7D5B"/>
+          </a:solidFill>
+          <a:ln w="12700">
+            <a:solidFill>
+              <a:srgbClr val="2E7D5B"/>
+            </a:solidFill>
+            <a:prstDash val="solid"/>
+          </a:ln>
+        </p:spPr>
+      </p:sp>
+      <p:sp>
+        <p:nvSpPr>
+          <p:cNvPr id="10" name="Text 7"/>
+          <p:cNvSpPr/>
+          <p:nvPr/>
+        </p:nvSpPr>
+        <p:spPr>
+          <a:xfrm>
+            <a:off x="9299448" y="109728"/>
+            <a:ext cx="2286000" cy="237744"/>
+          </a:xfrm>
+          <a:prstGeom prst="rect">
+            <a:avLst/>
+          </a:prstGeom>
+          <a:noFill/>
+          <a:ln/>
+        </p:spPr>
+        <p:txBody>
+          <a:bodyPr wrap="square" lIns="0" tIns="0" rIns="0" bIns="0" rtlCol="0" anchor="ctr"/>
+          <a:lstStyle/>
+          <a:p>
+            <a:pPr indent="0" marL="0">
+              <a:buNone/>
+            </a:pPr>
+            <a:r>
+              <a:rPr lang="en-US" sz="800" b="1" spc="100" kern="0" dirty="0">
+                <a:solidFill>
+                  <a:srgbClr val="9FB2C2"/>
+                </a:solidFill>
+                <a:latin typeface="Inter" pitchFamily="34" charset="0"/>
+                <a:ea typeface="Inter" pitchFamily="34" charset="-122"/>
+                <a:cs typeface="Inter" pitchFamily="34" charset="-120"/>
+              </a:rPr>
+              <a:t>MS. RIVERA'S SCREEN · SO FAR</a:t>
+            </a:r>
+            <a:endParaRPr lang="en-US" sz="800" dirty="0"/>
+          </a:p>
+        </p:txBody>
+      </p:sp>
+      <p:sp>
+        <p:nvSpPr>
+          <p:cNvPr id="11" name="Text 8"/>
+          <p:cNvSpPr/>
+          <p:nvPr/>
+        </p:nvSpPr>
+        <p:spPr>
+          <a:xfrm>
+            <a:off x="8860536" y="365760"/>
+            <a:ext cx="2670048" cy="566928"/>
+          </a:xfrm>
+          <a:prstGeom prst="rect">
+            <a:avLst/>
+          </a:prstGeom>
+          <a:noFill/>
+          <a:ln/>
+        </p:spPr>
+        <p:txBody>
+          <a:bodyPr wrap="square" lIns="0" tIns="0" rIns="0" bIns="0" rtlCol="0" anchor="ctr"/>
+          <a:lstStyle/>
+          <a:p>
+            <a:pPr indent="0" marL="0">
+              <a:buNone/>
+            </a:pPr>
+            <a:r>
+              <a:rPr lang="en-US" sz="1000" dirty="0">
+                <a:solidFill>
+                  <a:srgbClr val="1B1F24"/>
+                </a:solidFill>
+                <a:latin typeface="Inter" pitchFamily="34" charset="0"/>
+                <a:ea typeface="Inter" pitchFamily="34" charset="-122"/>
+                <a:cs typeface="Inter" pitchFamily="34" charset="-120"/>
+              </a:rPr>
+              <a:t>Her newsletter blurb, v3: two pushbacks later, hers. One invented detail caught.</a:t>
+            </a:r>
+            <a:endParaRPr lang="en-US" sz="1000" dirty="0"/>
+          </a:p>
+        </p:txBody>
+      </p:sp>
+      <p:sp>
+        <p:nvSpPr>
+          <p:cNvPr id="12" name="Text 9"/>
           <p:cNvSpPr/>
           <p:nvPr/>
         </p:nvSpPr>
@@ -13977,14 +14553,14 @@
       </p:sp>
       <p:sp>
         <p:nvSpPr>
-          <p:cNvPr id="6" name="Text 3"/>
+          <p:cNvPr id="13" name="Text 10"/>
           <p:cNvSpPr/>
           <p:nvPr/>
         </p:nvSpPr>
         <p:spPr>
           <a:xfrm>
             <a:off x="548640" y="384048"/>
-            <a:ext cx="11091672" cy="777240"/>
+            <a:ext cx="7955280" cy="777240"/>
           </a:xfrm>
           <a:prstGeom prst="rect">
             <a:avLst/>
@@ -14016,30 +14592,30 @@
       </p:sp>
       <p:sp>
         <p:nvSpPr>
-          <p:cNvPr id="7" name="Text 4"/>
-          <p:cNvSpPr/>
-          <p:nvPr/>
-        </p:nvSpPr>
-        <p:spPr>
-          <a:xfrm>
-            <a:off x="640080" y="1371600"/>
-            <a:ext cx="10972800" cy="502920"/>
-          </a:xfrm>
-          <a:prstGeom prst="rect">
-            <a:avLst/>
-          </a:prstGeom>
-          <a:noFill/>
-          <a:ln/>
-        </p:spPr>
-        <p:txBody>
-          <a:bodyPr wrap="square" lIns="0" tIns="0" rIns="0" bIns="0" rtlCol="0" anchor="ctr"/>
-          <a:lstStyle/>
-          <a:p>
-            <a:pPr indent="0" marL="0">
-              <a:buNone/>
-            </a:pPr>
-            <a:r>
-              <a:rPr lang="en-US" sz="2000" dirty="0">
+          <p:cNvPr id="14" name="Text 11"/>
+          <p:cNvSpPr/>
+          <p:nvPr/>
+        </p:nvSpPr>
+        <p:spPr>
+          <a:xfrm>
+            <a:off x="640080" y="1335024"/>
+            <a:ext cx="5074920" cy="640080"/>
+          </a:xfrm>
+          <a:prstGeom prst="rect">
+            <a:avLst/>
+          </a:prstGeom>
+          <a:noFill/>
+          <a:ln/>
+        </p:spPr>
+        <p:txBody>
+          <a:bodyPr wrap="square" lIns="0" tIns="0" rIns="0" bIns="0" rtlCol="0" anchor="t"/>
+          <a:lstStyle/>
+          <a:p>
+            <a:pPr indent="0" marL="0">
+              <a:buNone/>
+            </a:pPr>
+            <a:r>
+              <a:rPr lang="en-US" sz="1550" dirty="0">
                 <a:solidFill>
                   <a:srgbClr val="1B1F24"/>
                 </a:solidFill>
@@ -14047,26 +14623,26 @@
                 <a:ea typeface="Inter" pitchFamily="34" charset="-122"/>
                 <a:cs typeface="Inter" pitchFamily="34" charset="-120"/>
               </a:rPr>
-              <a:t>Don’t accept the first draft. Tell it what’s wrong, like you would an intern. Ms. Rivera’s replies, one at a time:</a:t>
-            </a:r>
-            <a:endParaRPr lang="en-US" sz="2000" dirty="0"/>
-          </a:p>
-        </p:txBody>
-      </p:sp>
-      <p:sp>
-        <p:nvSpPr>
-          <p:cNvPr id="8" name="Shape 5"/>
-          <p:cNvSpPr/>
-          <p:nvPr/>
-        </p:nvSpPr>
-        <p:spPr>
-          <a:xfrm>
-            <a:off x="3291840" y="2103120"/>
-            <a:ext cx="7863840" cy="713232"/>
+              <a:t>Don’t accept the first draft. Tell it what’s wrong, like you would an intern:</a:t>
+            </a:r>
+            <a:endParaRPr lang="en-US" sz="1550" dirty="0"/>
+          </a:p>
+        </p:txBody>
+      </p:sp>
+      <p:sp>
+        <p:nvSpPr>
+          <p:cNvPr id="15" name="Shape 12"/>
+          <p:cNvSpPr/>
+          <p:nvPr/>
+        </p:nvSpPr>
+        <p:spPr>
+          <a:xfrm>
+            <a:off x="640080" y="2011680"/>
+            <a:ext cx="5074920" cy="768096"/>
           </a:xfrm>
           <a:prstGeom prst="roundRect">
             <a:avLst>
-              <a:gd name="adj" fmla="val 15385"/>
+              <a:gd name="adj" fmla="val 14286"/>
             </a:avLst>
           </a:prstGeom>
           <a:solidFill>
@@ -14082,30 +14658,30 @@
       </p:sp>
       <p:sp>
         <p:nvSpPr>
-          <p:cNvPr id="9" name="Text 6"/>
-          <p:cNvSpPr/>
-          <p:nvPr/>
-        </p:nvSpPr>
-        <p:spPr>
-          <a:xfrm>
-            <a:off x="3611880" y="2148840"/>
-            <a:ext cx="7315200" cy="621792"/>
-          </a:xfrm>
-          <a:prstGeom prst="rect">
-            <a:avLst/>
-          </a:prstGeom>
-          <a:noFill/>
-          <a:ln/>
-        </p:spPr>
-        <p:txBody>
-          <a:bodyPr wrap="square" lIns="0" tIns="0" rIns="0" bIns="0" rtlCol="0" anchor="ctr"/>
-          <a:lstStyle/>
-          <a:p>
-            <a:pPr indent="0" marL="0">
-              <a:buNone/>
-            </a:pPr>
-            <a:r>
-              <a:rPr lang="en-US" sz="1900" b="1" dirty="0">
+          <p:cNvPr id="16" name="Text 13"/>
+          <p:cNvSpPr/>
+          <p:nvPr/>
+        </p:nvSpPr>
+        <p:spPr>
+          <a:xfrm>
+            <a:off x="896112" y="2057400"/>
+            <a:ext cx="4572000" cy="676656"/>
+          </a:xfrm>
+          <a:prstGeom prst="rect">
+            <a:avLst/>
+          </a:prstGeom>
+          <a:noFill/>
+          <a:ln/>
+        </p:spPr>
+        <p:txBody>
+          <a:bodyPr wrap="square" lIns="0" tIns="0" rIns="0" bIns="0" rtlCol="0" anchor="ctr"/>
+          <a:lstStyle/>
+          <a:p>
+            <a:pPr indent="0" marL="0">
+              <a:buNone/>
+            </a:pPr>
+            <a:r>
+              <a:rPr lang="en-US" sz="1500" b="1" dirty="0">
                 <a:solidFill>
                   <a:srgbClr val="13293D"/>
                 </a:solidFill>
@@ -14115,63 +14691,24 @@
               </a:rPr>
               <a:t>“Warmer.”</a:t>
             </a:r>
-            <a:endParaRPr lang="en-US" sz="1900" dirty="0"/>
-          </a:p>
-        </p:txBody>
-      </p:sp>
-      <p:sp>
-        <p:nvSpPr>
-          <p:cNvPr id="10" name="Text 7"/>
-          <p:cNvSpPr/>
-          <p:nvPr/>
-        </p:nvSpPr>
-        <p:spPr>
-          <a:xfrm>
-            <a:off x="1965960" y="2148840"/>
-            <a:ext cx="1234440" cy="621792"/>
-          </a:xfrm>
-          <a:prstGeom prst="rect">
-            <a:avLst/>
-          </a:prstGeom>
-          <a:noFill/>
-          <a:ln/>
-        </p:spPr>
-        <p:txBody>
-          <a:bodyPr wrap="square" lIns="0" tIns="0" rIns="0" bIns="0" rtlCol="0" anchor="ctr"/>
-          <a:lstStyle/>
-          <a:p>
-            <a:pPr algn="r" indent="0" marL="0">
-              <a:buNone/>
-            </a:pPr>
-            <a:r>
-              <a:rPr lang="en-US" sz="1200" i="1" dirty="0">
-                <a:solidFill>
-                  <a:srgbClr val="5B6B7A"/>
-                </a:solidFill>
-                <a:latin typeface="Inter" pitchFamily="34" charset="0"/>
-                <a:ea typeface="Inter" pitchFamily="34" charset="-122"/>
-                <a:cs typeface="Inter" pitchFamily="34" charset="-120"/>
-              </a:rPr>
-              <a:t>she types →</a:t>
-            </a:r>
-            <a:endParaRPr lang="en-US" sz="1200" dirty="0"/>
-          </a:p>
-        </p:txBody>
-      </p:sp>
-      <p:sp>
-        <p:nvSpPr>
-          <p:cNvPr id="11" name="Shape 8"/>
-          <p:cNvSpPr/>
-          <p:nvPr/>
-        </p:nvSpPr>
-        <p:spPr>
-          <a:xfrm>
-            <a:off x="3291840" y="2971800"/>
-            <a:ext cx="7863840" cy="713232"/>
+            <a:endParaRPr lang="en-US" sz="1500" dirty="0"/>
+          </a:p>
+        </p:txBody>
+      </p:sp>
+      <p:sp>
+        <p:nvSpPr>
+          <p:cNvPr id="17" name="Shape 14"/>
+          <p:cNvSpPr/>
+          <p:nvPr/>
+        </p:nvSpPr>
+        <p:spPr>
+          <a:xfrm>
+            <a:off x="640080" y="2907792"/>
+            <a:ext cx="5074920" cy="768096"/>
           </a:xfrm>
           <a:prstGeom prst="roundRect">
             <a:avLst>
-              <a:gd name="adj" fmla="val 15385"/>
+              <a:gd name="adj" fmla="val 14286"/>
             </a:avLst>
           </a:prstGeom>
           <a:solidFill>
@@ -14187,30 +14724,30 @@
       </p:sp>
       <p:sp>
         <p:nvSpPr>
-          <p:cNvPr id="12" name="Text 9"/>
-          <p:cNvSpPr/>
-          <p:nvPr/>
-        </p:nvSpPr>
-        <p:spPr>
-          <a:xfrm>
-            <a:off x="3611880" y="3017520"/>
-            <a:ext cx="7315200" cy="621792"/>
-          </a:xfrm>
-          <a:prstGeom prst="rect">
-            <a:avLst/>
-          </a:prstGeom>
-          <a:noFill/>
-          <a:ln/>
-        </p:spPr>
-        <p:txBody>
-          <a:bodyPr wrap="square" lIns="0" tIns="0" rIns="0" bIns="0" rtlCol="0" anchor="ctr"/>
-          <a:lstStyle/>
-          <a:p>
-            <a:pPr indent="0" marL="0">
-              <a:buNone/>
-            </a:pPr>
-            <a:r>
-              <a:rPr lang="en-US" sz="1900" b="1" dirty="0">
+          <p:cNvPr id="18" name="Text 15"/>
+          <p:cNvSpPr/>
+          <p:nvPr/>
+        </p:nvSpPr>
+        <p:spPr>
+          <a:xfrm>
+            <a:off x="896112" y="2953512"/>
+            <a:ext cx="4572000" cy="676656"/>
+          </a:xfrm>
+          <a:prstGeom prst="rect">
+            <a:avLst/>
+          </a:prstGeom>
+          <a:noFill/>
+          <a:ln/>
+        </p:spPr>
+        <p:txBody>
+          <a:bodyPr wrap="square" lIns="0" tIns="0" rIns="0" bIns="0" rtlCol="0" anchor="ctr"/>
+          <a:lstStyle/>
+          <a:p>
+            <a:pPr indent="0" marL="0">
+              <a:buNone/>
+            </a:pPr>
+            <a:r>
+              <a:rPr lang="en-US" sz="1500" b="1" dirty="0">
                 <a:solidFill>
                   <a:srgbClr val="13293D"/>
                 </a:solidFill>
@@ -14220,63 +14757,24 @@
               </a:rPr>
               <a:t>“Shorter.”</a:t>
             </a:r>
-            <a:endParaRPr lang="en-US" sz="1900" dirty="0"/>
-          </a:p>
-        </p:txBody>
-      </p:sp>
-      <p:sp>
-        <p:nvSpPr>
-          <p:cNvPr id="13" name="Text 10"/>
-          <p:cNvSpPr/>
-          <p:nvPr/>
-        </p:nvSpPr>
-        <p:spPr>
-          <a:xfrm>
-            <a:off x="1965960" y="3017520"/>
-            <a:ext cx="1234440" cy="621792"/>
-          </a:xfrm>
-          <a:prstGeom prst="rect">
-            <a:avLst/>
-          </a:prstGeom>
-          <a:noFill/>
-          <a:ln/>
-        </p:spPr>
-        <p:txBody>
-          <a:bodyPr wrap="square" lIns="0" tIns="0" rIns="0" bIns="0" rtlCol="0" anchor="ctr"/>
-          <a:lstStyle/>
-          <a:p>
-            <a:pPr algn="r" indent="0" marL="0">
-              <a:buNone/>
-            </a:pPr>
-            <a:r>
-              <a:rPr lang="en-US" sz="1200" i="1" dirty="0">
-                <a:solidFill>
-                  <a:srgbClr val="5B6B7A"/>
-                </a:solidFill>
-                <a:latin typeface="Inter" pitchFamily="34" charset="0"/>
-                <a:ea typeface="Inter" pitchFamily="34" charset="-122"/>
-                <a:cs typeface="Inter" pitchFamily="34" charset="-120"/>
-              </a:rPr>
-              <a:t>she types →</a:t>
-            </a:r>
-            <a:endParaRPr lang="en-US" sz="1200" dirty="0"/>
-          </a:p>
-        </p:txBody>
-      </p:sp>
-      <p:sp>
-        <p:nvSpPr>
-          <p:cNvPr id="14" name="Shape 11"/>
-          <p:cNvSpPr/>
-          <p:nvPr/>
-        </p:nvSpPr>
-        <p:spPr>
-          <a:xfrm>
-            <a:off x="3291840" y="3840480"/>
-            <a:ext cx="7863840" cy="713232"/>
+            <a:endParaRPr lang="en-US" sz="1500" dirty="0"/>
+          </a:p>
+        </p:txBody>
+      </p:sp>
+      <p:sp>
+        <p:nvSpPr>
+          <p:cNvPr id="19" name="Shape 16"/>
+          <p:cNvSpPr/>
+          <p:nvPr/>
+        </p:nvSpPr>
+        <p:spPr>
+          <a:xfrm>
+            <a:off x="640080" y="3803904"/>
+            <a:ext cx="5074920" cy="768096"/>
           </a:xfrm>
           <a:prstGeom prst="roundRect">
             <a:avLst>
-              <a:gd name="adj" fmla="val 15385"/>
+              <a:gd name="adj" fmla="val 14286"/>
             </a:avLst>
           </a:prstGeom>
           <a:solidFill>
@@ -14292,30 +14790,30 @@
       </p:sp>
       <p:sp>
         <p:nvSpPr>
-          <p:cNvPr id="15" name="Text 12"/>
-          <p:cNvSpPr/>
-          <p:nvPr/>
-        </p:nvSpPr>
-        <p:spPr>
-          <a:xfrm>
-            <a:off x="3611880" y="3886200"/>
-            <a:ext cx="7315200" cy="621792"/>
-          </a:xfrm>
-          <a:prstGeom prst="rect">
-            <a:avLst/>
-          </a:prstGeom>
-          <a:noFill/>
-          <a:ln/>
-        </p:spPr>
-        <p:txBody>
-          <a:bodyPr wrap="square" lIns="0" tIns="0" rIns="0" bIns="0" rtlCol="0" anchor="ctr"/>
-          <a:lstStyle/>
-          <a:p>
-            <a:pPr indent="0" marL="0">
-              <a:buNone/>
-            </a:pPr>
-            <a:r>
-              <a:rPr lang="en-US" sz="1900" b="1" dirty="0">
+          <p:cNvPr id="20" name="Text 17"/>
+          <p:cNvSpPr/>
+          <p:nvPr/>
+        </p:nvSpPr>
+        <p:spPr>
+          <a:xfrm>
+            <a:off x="896112" y="3849624"/>
+            <a:ext cx="4572000" cy="676656"/>
+          </a:xfrm>
+          <a:prstGeom prst="rect">
+            <a:avLst/>
+          </a:prstGeom>
+          <a:noFill/>
+          <a:ln/>
+        </p:spPr>
+        <p:txBody>
+          <a:bodyPr wrap="square" lIns="0" tIns="0" rIns="0" bIns="0" rtlCol="0" anchor="ctr"/>
+          <a:lstStyle/>
+          <a:p>
+            <a:pPr indent="0" marL="0">
+              <a:buNone/>
+            </a:pPr>
+            <a:r>
+              <a:rPr lang="en-US" sz="1500" b="1" dirty="0">
                 <a:solidFill>
                   <a:srgbClr val="13293D"/>
                 </a:solidFill>
@@ -14325,63 +14823,24 @@
               </a:rPr>
               <a:t>“A 5th grader wouldn’t know three of these words. Fix that.”</a:t>
             </a:r>
-            <a:endParaRPr lang="en-US" sz="1900" dirty="0"/>
-          </a:p>
-        </p:txBody>
-      </p:sp>
-      <p:sp>
-        <p:nvSpPr>
-          <p:cNvPr id="16" name="Text 13"/>
-          <p:cNvSpPr/>
-          <p:nvPr/>
-        </p:nvSpPr>
-        <p:spPr>
-          <a:xfrm>
-            <a:off x="1965960" y="3886200"/>
-            <a:ext cx="1234440" cy="621792"/>
-          </a:xfrm>
-          <a:prstGeom prst="rect">
-            <a:avLst/>
-          </a:prstGeom>
-          <a:noFill/>
-          <a:ln/>
-        </p:spPr>
-        <p:txBody>
-          <a:bodyPr wrap="square" lIns="0" tIns="0" rIns="0" bIns="0" rtlCol="0" anchor="ctr"/>
-          <a:lstStyle/>
-          <a:p>
-            <a:pPr algn="r" indent="0" marL="0">
-              <a:buNone/>
-            </a:pPr>
-            <a:r>
-              <a:rPr lang="en-US" sz="1200" i="1" dirty="0">
-                <a:solidFill>
-                  <a:srgbClr val="5B6B7A"/>
-                </a:solidFill>
-                <a:latin typeface="Inter" pitchFamily="34" charset="0"/>
-                <a:ea typeface="Inter" pitchFamily="34" charset="-122"/>
-                <a:cs typeface="Inter" pitchFamily="34" charset="-120"/>
-              </a:rPr>
-              <a:t>she types →</a:t>
-            </a:r>
-            <a:endParaRPr lang="en-US" sz="1200" dirty="0"/>
-          </a:p>
-        </p:txBody>
-      </p:sp>
-      <p:sp>
-        <p:nvSpPr>
-          <p:cNvPr id="17" name="Shape 14"/>
-          <p:cNvSpPr/>
-          <p:nvPr/>
-        </p:nvSpPr>
-        <p:spPr>
-          <a:xfrm>
-            <a:off x="3291840" y="4709160"/>
-            <a:ext cx="7863840" cy="713232"/>
+            <a:endParaRPr lang="en-US" sz="1500" dirty="0"/>
+          </a:p>
+        </p:txBody>
+      </p:sp>
+      <p:sp>
+        <p:nvSpPr>
+          <p:cNvPr id="21" name="Shape 18"/>
+          <p:cNvSpPr/>
+          <p:nvPr/>
+        </p:nvSpPr>
+        <p:spPr>
+          <a:xfrm>
+            <a:off x="640080" y="4700016"/>
+            <a:ext cx="5074920" cy="768096"/>
           </a:xfrm>
           <a:prstGeom prst="roundRect">
             <a:avLst>
-              <a:gd name="adj" fmla="val 15385"/>
+              <a:gd name="adj" fmla="val 14286"/>
             </a:avLst>
           </a:prstGeom>
           <a:solidFill>
@@ -14397,30 +14856,30 @@
       </p:sp>
       <p:sp>
         <p:nvSpPr>
-          <p:cNvPr id="18" name="Text 15"/>
-          <p:cNvSpPr/>
-          <p:nvPr/>
-        </p:nvSpPr>
-        <p:spPr>
-          <a:xfrm>
-            <a:off x="3611880" y="4754880"/>
-            <a:ext cx="7315200" cy="621792"/>
-          </a:xfrm>
-          <a:prstGeom prst="rect">
-            <a:avLst/>
-          </a:prstGeom>
-          <a:noFill/>
-          <a:ln/>
-        </p:spPr>
-        <p:txBody>
-          <a:bodyPr wrap="square" lIns="0" tIns="0" rIns="0" bIns="0" rtlCol="0" anchor="ctr"/>
-          <a:lstStyle/>
-          <a:p>
-            <a:pPr indent="0" marL="0">
-              <a:buNone/>
-            </a:pPr>
-            <a:r>
-              <a:rPr lang="en-US" sz="1900" b="1" dirty="0">
+          <p:cNvPr id="22" name="Text 19"/>
+          <p:cNvSpPr/>
+          <p:nvPr/>
+        </p:nvSpPr>
+        <p:spPr>
+          <a:xfrm>
+            <a:off x="896112" y="4745736"/>
+            <a:ext cx="4572000" cy="676656"/>
+          </a:xfrm>
+          <a:prstGeom prst="rect">
+            <a:avLst/>
+          </a:prstGeom>
+          <a:noFill/>
+          <a:ln/>
+        </p:spPr>
+        <p:txBody>
+          <a:bodyPr wrap="square" lIns="0" tIns="0" rIns="0" bIns="0" rtlCol="0" anchor="ctr"/>
+          <a:lstStyle/>
+          <a:p>
+            <a:pPr indent="0" marL="0">
+              <a:buNone/>
+            </a:pPr>
+            <a:r>
+              <a:rPr lang="en-US" sz="1500" b="1" dirty="0">
                 <a:solidFill>
                   <a:srgbClr val="13293D"/>
                 </a:solidFill>
@@ -14430,36 +14889,282 @@
               </a:rPr>
               <a:t>“Make question four harder and add a diagram question.”</a:t>
             </a:r>
-            <a:endParaRPr lang="en-US" sz="1900" dirty="0"/>
-          </a:p>
-        </p:txBody>
-      </p:sp>
-      <p:sp>
-        <p:nvSpPr>
-          <p:cNvPr id="19" name="Text 16"/>
-          <p:cNvSpPr/>
-          <p:nvPr/>
-        </p:nvSpPr>
-        <p:spPr>
-          <a:xfrm>
-            <a:off x="1965960" y="4754880"/>
-            <a:ext cx="1234440" cy="621792"/>
-          </a:xfrm>
-          <a:prstGeom prst="rect">
-            <a:avLst/>
-          </a:prstGeom>
-          <a:noFill/>
-          <a:ln/>
-        </p:spPr>
-        <p:txBody>
-          <a:bodyPr wrap="square" lIns="0" tIns="0" rIns="0" bIns="0" rtlCol="0" anchor="ctr"/>
-          <a:lstStyle/>
-          <a:p>
-            <a:pPr algn="r" indent="0" marL="0">
-              <a:buNone/>
-            </a:pPr>
-            <a:r>
-              <a:rPr lang="en-US" sz="1200" i="1" dirty="0">
+            <a:endParaRPr lang="en-US" sz="1500" dirty="0"/>
+          </a:p>
+        </p:txBody>
+      </p:sp>
+      <p:sp>
+        <p:nvSpPr>
+          <p:cNvPr id="23" name="Shape 20"/>
+          <p:cNvSpPr/>
+          <p:nvPr/>
+        </p:nvSpPr>
+        <p:spPr>
+          <a:xfrm>
+            <a:off x="5897880" y="1298448"/>
+            <a:ext cx="5715000" cy="4315968"/>
+          </a:xfrm>
+          <a:prstGeom prst="roundRect">
+            <a:avLst>
+              <a:gd name="adj" fmla="val 2119"/>
+            </a:avLst>
+          </a:prstGeom>
+          <a:solidFill>
+            <a:srgbClr val="FFFFFF"/>
+          </a:solidFill>
+          <a:ln w="19050">
+            <a:solidFill>
+              <a:srgbClr val="DCE3EA"/>
+            </a:solidFill>
+            <a:prstDash val="solid"/>
+          </a:ln>
+        </p:spPr>
+      </p:sp>
+      <p:sp>
+        <p:nvSpPr>
+          <p:cNvPr id="24" name="Shape 21"/>
+          <p:cNvSpPr/>
+          <p:nvPr/>
+        </p:nvSpPr>
+        <p:spPr>
+          <a:xfrm>
+            <a:off x="5897880" y="1298448"/>
+            <a:ext cx="5715000" cy="384048"/>
+          </a:xfrm>
+          <a:prstGeom prst="roundRect">
+            <a:avLst>
+              <a:gd name="adj" fmla="val 23810"/>
+            </a:avLst>
+          </a:prstGeom>
+          <a:solidFill>
+            <a:srgbClr val="13293D"/>
+          </a:solidFill>
+          <a:ln w="12700">
+            <a:solidFill>
+              <a:srgbClr val="13293D"/>
+            </a:solidFill>
+            <a:prstDash val="solid"/>
+          </a:ln>
+        </p:spPr>
+      </p:sp>
+      <p:sp>
+        <p:nvSpPr>
+          <p:cNvPr id="25" name="Shape 22"/>
+          <p:cNvSpPr/>
+          <p:nvPr/>
+        </p:nvSpPr>
+        <p:spPr>
+          <a:xfrm>
+            <a:off x="6099048" y="1417320"/>
+            <a:ext cx="146304" cy="146304"/>
+          </a:xfrm>
+          <a:prstGeom prst="ellipse">
+            <a:avLst/>
+          </a:prstGeom>
+          <a:solidFill>
+            <a:srgbClr val="E8837A"/>
+          </a:solidFill>
+          <a:ln w="12700">
+            <a:solidFill>
+              <a:srgbClr val="E8837A"/>
+            </a:solidFill>
+            <a:prstDash val="solid"/>
+          </a:ln>
+        </p:spPr>
+      </p:sp>
+      <p:sp>
+        <p:nvSpPr>
+          <p:cNvPr id="26" name="Shape 23"/>
+          <p:cNvSpPr/>
+          <p:nvPr/>
+        </p:nvSpPr>
+        <p:spPr>
+          <a:xfrm>
+            <a:off x="6345936" y="1417320"/>
+            <a:ext cx="146304" cy="146304"/>
+          </a:xfrm>
+          <a:prstGeom prst="ellipse">
+            <a:avLst/>
+          </a:prstGeom>
+          <a:solidFill>
+            <a:srgbClr val="F4A825"/>
+          </a:solidFill>
+          <a:ln w="12700">
+            <a:solidFill>
+              <a:srgbClr val="F4A825"/>
+            </a:solidFill>
+            <a:prstDash val="solid"/>
+          </a:ln>
+        </p:spPr>
+      </p:sp>
+      <p:sp>
+        <p:nvSpPr>
+          <p:cNvPr id="27" name="Shape 24"/>
+          <p:cNvSpPr/>
+          <p:nvPr/>
+        </p:nvSpPr>
+        <p:spPr>
+          <a:xfrm>
+            <a:off x="6592824" y="1417320"/>
+            <a:ext cx="146304" cy="146304"/>
+          </a:xfrm>
+          <a:prstGeom prst="ellipse">
+            <a:avLst/>
+          </a:prstGeom>
+          <a:solidFill>
+            <a:srgbClr val="2E7D5B"/>
+          </a:solidFill>
+          <a:ln w="12700">
+            <a:solidFill>
+              <a:srgbClr val="2E7D5B"/>
+            </a:solidFill>
+            <a:prstDash val="solid"/>
+          </a:ln>
+        </p:spPr>
+      </p:sp>
+      <p:sp>
+        <p:nvSpPr>
+          <p:cNvPr id="28" name="Text 25"/>
+          <p:cNvSpPr/>
+          <p:nvPr/>
+        </p:nvSpPr>
+        <p:spPr>
+          <a:xfrm>
+            <a:off x="6949440" y="1298448"/>
+            <a:ext cx="4526280" cy="384048"/>
+          </a:xfrm>
+          <a:prstGeom prst="rect">
+            <a:avLst/>
+          </a:prstGeom>
+          <a:noFill/>
+          <a:ln/>
+        </p:spPr>
+        <p:txBody>
+          <a:bodyPr wrap="square" lIns="0" tIns="0" rIns="0" bIns="0" rtlCol="0" anchor="ctr"/>
+          <a:lstStyle/>
+          <a:p>
+            <a:pPr indent="0" marL="0">
+              <a:buNone/>
+            </a:pPr>
+            <a:r>
+              <a:rPr lang="en-US" sz="1100" dirty="0">
+                <a:solidFill>
+                  <a:srgbClr val="9FB2C2"/>
+                </a:solidFill>
+                <a:latin typeface="Inter" pitchFamily="34" charset="0"/>
+                <a:ea typeface="Inter" pitchFamily="34" charset="-122"/>
+                <a:cs typeface="Inter" pitchFamily="34" charset="-120"/>
+              </a:rPr>
+              <a:t>Ms. Rivera’s newsletter blurb · task 2 · two pushbacks later</a:t>
+            </a:r>
+            <a:endParaRPr lang="en-US" sz="1100" dirty="0"/>
+          </a:p>
+        </p:txBody>
+      </p:sp>
+      <p:sp>
+        <p:nvSpPr>
+          <p:cNvPr id="29" name="Text 26"/>
+          <p:cNvSpPr/>
+          <p:nvPr/>
+        </p:nvSpPr>
+        <p:spPr>
+          <a:xfrm>
+            <a:off x="6172200" y="1792224"/>
+            <a:ext cx="5166360" cy="256032"/>
+          </a:xfrm>
+          <a:prstGeom prst="rect">
+            <a:avLst/>
+          </a:prstGeom>
+          <a:noFill/>
+          <a:ln/>
+        </p:spPr>
+        <p:txBody>
+          <a:bodyPr wrap="square" lIns="0" tIns="0" rIns="0" bIns="0" rtlCol="0" anchor="ctr"/>
+          <a:lstStyle/>
+          <a:p>
+            <a:pPr indent="0" marL="0">
+              <a:buNone/>
+            </a:pPr>
+            <a:r>
+              <a:rPr lang="en-US" sz="1000" b="1" spc="150" kern="0" dirty="0">
+                <a:solidFill>
+                  <a:srgbClr val="2A9D8F"/>
+                </a:solidFill>
+                <a:latin typeface="Inter" pitchFamily="34" charset="0"/>
+                <a:ea typeface="Inter" pitchFamily="34" charset="-122"/>
+                <a:cs typeface="Inter" pitchFamily="34" charset="-120"/>
+              </a:rPr>
+              <a:t>SHE TYPES, ONE AT A TIME</a:t>
+            </a:r>
+            <a:endParaRPr lang="en-US" sz="1000" dirty="0"/>
+          </a:p>
+        </p:txBody>
+      </p:sp>
+      <p:sp>
+        <p:nvSpPr>
+          <p:cNvPr id="30" name="Text 27"/>
+          <p:cNvSpPr/>
+          <p:nvPr/>
+        </p:nvSpPr>
+        <p:spPr>
+          <a:xfrm>
+            <a:off x="6172200" y="2048256"/>
+            <a:ext cx="5166360" cy="310896"/>
+          </a:xfrm>
+          <a:prstGeom prst="rect">
+            <a:avLst/>
+          </a:prstGeom>
+          <a:noFill/>
+          <a:ln/>
+        </p:spPr>
+        <p:txBody>
+          <a:bodyPr wrap="square" lIns="0" tIns="0" rIns="0" bIns="0" rtlCol="0" anchor="t"/>
+          <a:lstStyle/>
+          <a:p>
+            <a:pPr indent="0" marL="0">
+              <a:buNone/>
+            </a:pPr>
+            <a:r>
+              <a:rPr lang="en-US" sz="1550" b="1" dirty="0">
+                <a:solidFill>
+                  <a:srgbClr val="13293D"/>
+                </a:solidFill>
+                <a:latin typeface="Inter" pitchFamily="34" charset="0"/>
+                <a:ea typeface="Inter" pitchFamily="34" charset="-122"/>
+                <a:cs typeface="Inter" pitchFamily="34" charset="-120"/>
+              </a:rPr>
+              <a:t>“Warmer.”   then   “Shorter.”</a:t>
+            </a:r>
+            <a:endParaRPr lang="en-US" sz="1550" dirty="0"/>
+          </a:p>
+        </p:txBody>
+      </p:sp>
+      <p:sp>
+        <p:nvSpPr>
+          <p:cNvPr id="31" name="Text 28"/>
+          <p:cNvSpPr/>
+          <p:nvPr/>
+        </p:nvSpPr>
+        <p:spPr>
+          <a:xfrm>
+            <a:off x="6172200" y="2468880"/>
+            <a:ext cx="5166360" cy="256032"/>
+          </a:xfrm>
+          <a:prstGeom prst="rect">
+            <a:avLst/>
+          </a:prstGeom>
+          <a:noFill/>
+          <a:ln/>
+        </p:spPr>
+        <p:txBody>
+          <a:bodyPr wrap="square" lIns="0" tIns="0" rIns="0" bIns="0" rtlCol="0" anchor="ctr"/>
+          <a:lstStyle/>
+          <a:p>
+            <a:pPr indent="0" marL="0">
+              <a:buNone/>
+            </a:pPr>
+            <a:r>
+              <a:rPr lang="en-US" sz="1000" b="1" spc="150" kern="0" dirty="0">
                 <a:solidFill>
                   <a:srgbClr val="5B6B7A"/>
                 </a:solidFill>
@@ -14467,15 +15172,177 @@
                 <a:ea typeface="Inter" pitchFamily="34" charset="-122"/>
                 <a:cs typeface="Inter" pitchFamily="34" charset="-120"/>
               </a:rPr>
-              <a:t>she types →</a:t>
-            </a:r>
-            <a:endParaRPr lang="en-US" sz="1200" dirty="0"/>
-          </a:p>
-        </p:txBody>
-      </p:sp>
-      <p:sp>
-        <p:nvSpPr>
-          <p:cNvPr id="20" name="Text 17"/>
+              <a:t>THE BLURB, TWO ROUNDS LATER</a:t>
+            </a:r>
+            <a:endParaRPr lang="en-US" sz="1000" dirty="0"/>
+          </a:p>
+        </p:txBody>
+      </p:sp>
+      <p:sp>
+        <p:nvSpPr>
+          <p:cNvPr id="32" name="Text 29"/>
+          <p:cNvSpPr/>
+          <p:nvPr/>
+        </p:nvSpPr>
+        <p:spPr>
+          <a:xfrm>
+            <a:off x="6172200" y="2724912"/>
+            <a:ext cx="5166360" cy="868680"/>
+          </a:xfrm>
+          <a:prstGeom prst="rect">
+            <a:avLst/>
+          </a:prstGeom>
+          <a:noFill/>
+          <a:ln/>
+        </p:spPr>
+        <p:txBody>
+          <a:bodyPr wrap="square" lIns="0" tIns="0" rIns="0" bIns="0" rtlCol="0" anchor="t"/>
+          <a:lstStyle/>
+          <a:p>
+            <a:pPr indent="0" marL="0">
+              <a:lnSpc>
+                <a:spcPct val="112000"/>
+              </a:lnSpc>
+              <a:buNone/>
+            </a:pPr>
+            <a:r>
+              <a:rPr lang="en-US" sz="1400" dirty="0">
+                <a:solidFill>
+                  <a:srgbClr val="1B1F24"/>
+                </a:solidFill>
+                <a:latin typeface="Inter" pitchFamily="34" charset="0"/>
+                <a:ea typeface="Inter" pitchFamily="34" charset="-122"/>
+                <a:cs typeface="Inter" pitchFamily="34" charset="-120"/>
+              </a:rPr>
+              <a:t>“Families, our fall book fair is almost here! Stop by the library with your reader and help them pick a book they’ll actually love. Happy reading!”</a:t>
+            </a:r>
+            <a:endParaRPr lang="en-US" sz="1400" dirty="0"/>
+          </a:p>
+        </p:txBody>
+      </p:sp>
+      <p:sp>
+        <p:nvSpPr>
+          <p:cNvPr id="33" name="Text 30"/>
+          <p:cNvSpPr/>
+          <p:nvPr/>
+        </p:nvSpPr>
+        <p:spPr>
+          <a:xfrm>
+            <a:off x="6172200" y="3675888"/>
+            <a:ext cx="5166360" cy="256032"/>
+          </a:xfrm>
+          <a:prstGeom prst="rect">
+            <a:avLst/>
+          </a:prstGeom>
+          <a:noFill/>
+          <a:ln/>
+        </p:spPr>
+        <p:txBody>
+          <a:bodyPr wrap="square" lIns="0" tIns="0" rIns="0" bIns="0" rtlCol="0" anchor="ctr"/>
+          <a:lstStyle/>
+          <a:p>
+            <a:pPr indent="0" marL="0">
+              <a:buNone/>
+            </a:pPr>
+            <a:r>
+              <a:rPr lang="en-US" sz="1000" b="1" spc="150" kern="0" dirty="0">
+                <a:solidFill>
+                  <a:srgbClr val="B4453A"/>
+                </a:solidFill>
+                <a:latin typeface="Inter" pitchFamily="34" charset="0"/>
+                <a:ea typeface="Inter" pitchFamily="34" charset="-122"/>
+                <a:cs typeface="Inter" pitchFamily="34" charset="-120"/>
+              </a:rPr>
+              <a:t>ONE ERROR, CAUGHT ON THE READ-THROUGH</a:t>
+            </a:r>
+            <a:endParaRPr lang="en-US" sz="1000" dirty="0"/>
+          </a:p>
+        </p:txBody>
+      </p:sp>
+      <p:sp>
+        <p:nvSpPr>
+          <p:cNvPr id="34" name="Text 31"/>
+          <p:cNvSpPr/>
+          <p:nvPr/>
+        </p:nvSpPr>
+        <p:spPr>
+          <a:xfrm>
+            <a:off x="6172200" y="3931920"/>
+            <a:ext cx="5166360" cy="868680"/>
+          </a:xfrm>
+          <a:prstGeom prst="rect">
+            <a:avLst/>
+          </a:prstGeom>
+          <a:noFill/>
+          <a:ln/>
+        </p:spPr>
+        <p:txBody>
+          <a:bodyPr wrap="square" lIns="0" tIns="0" rIns="0" bIns="0" rtlCol="0" anchor="t"/>
+          <a:lstStyle/>
+          <a:p>
+            <a:pPr indent="0" marL="0">
+              <a:lnSpc>
+                <a:spcPct val="110000"/>
+              </a:lnSpc>
+              <a:buNone/>
+            </a:pPr>
+            <a:r>
+              <a:rPr lang="en-US" sz="1250" dirty="0">
+                <a:solidFill>
+                  <a:srgbClr val="1B1F24"/>
+                </a:solidFill>
+                <a:latin typeface="Inter" pitchFamily="34" charset="0"/>
+                <a:ea typeface="Inter" pitchFamily="34" charset="-122"/>
+                <a:cs typeface="Inter" pitchFamily="34" charset="-120"/>
+              </a:rPr>
+              <a:t>The draft claimed the fair “runs all week, 8:00 to 3:00.” She never typed a schedule; the intern invented one. She cut it and checked the real flyer.</a:t>
+            </a:r>
+            <a:endParaRPr lang="en-US" sz="1250" dirty="0"/>
+          </a:p>
+        </p:txBody>
+      </p:sp>
+      <p:sp>
+        <p:nvSpPr>
+          <p:cNvPr id="35" name="Text 32"/>
+          <p:cNvSpPr/>
+          <p:nvPr/>
+        </p:nvSpPr>
+        <p:spPr>
+          <a:xfrm>
+            <a:off x="6172200" y="4892040"/>
+            <a:ext cx="5166360" cy="594360"/>
+          </a:xfrm>
+          <a:prstGeom prst="rect">
+            <a:avLst/>
+          </a:prstGeom>
+          <a:noFill/>
+          <a:ln/>
+        </p:spPr>
+        <p:txBody>
+          <a:bodyPr wrap="square" lIns="0" tIns="0" rIns="0" bIns="0" rtlCol="0" anchor="t"/>
+          <a:lstStyle/>
+          <a:p>
+            <a:pPr indent="0" marL="0">
+              <a:buNone/>
+            </a:pPr>
+            <a:r>
+              <a:rPr lang="en-US" sz="1150" i="1" dirty="0">
+                <a:solidFill>
+                  <a:srgbClr val="5B6B7A"/>
+                </a:solidFill>
+                <a:latin typeface="Inter" pitchFamily="34" charset="0"/>
+                <a:ea typeface="Inter" pitchFamily="34" charset="-122"/>
+                <a:cs typeface="Inter" pitchFamily="34" charset="-120"/>
+              </a:rPr>
+              <a:t>Usable now, with nothing in it she didn’t verify. Copy her arc: draft, push back twice, read it before it goes anywhere.</a:t>
+            </a:r>
+            <a:endParaRPr lang="en-US" sz="1150" dirty="0"/>
+          </a:p>
+        </p:txBody>
+      </p:sp>
+      <p:sp>
+        <p:nvSpPr>
+          <p:cNvPr id="36" name="Text 33"/>
           <p:cNvSpPr/>
           <p:nvPr/>
         </p:nvSpPr>
@@ -14861,7 +15728,7 @@
                 <a:ea typeface="Inter" pitchFamily="34" charset="-122"/>
                 <a:cs typeface="Inter" pitchFamily="34" charset="-120"/>
               </a:rPr>
-              <a:t>Her lab notes: draft one beige; two pushbacks later, usable. One error caught.</a:t>
+              <a:t>Her newsletter blurb's arc: beige v1, two pushbacks, usable. One error caught.</a:t>
             </a:r>
             <a:endParaRPr lang="en-US" sz="1000" dirty="0"/>
           </a:p>

</xml_diff>

<commit_message>
Audit fixes: chip-zone collisions, Kit 1 handout break, Kit 4's 0.79
Overlapping text had one structural cause: titles and kickers ran the
full slide width into Ms. Rivera's tracker chip, patched slide by slide
before and unevenly. The title and kicker helpers now stop at 9.3 on any
slide that carries a chip, and long titles step down a size, so the
collision cannot recur. Applied to Kits 1-4 and both TpT editions;
Kits 5-8 wait on the owner's assessment.

Kit 1's starter-prompt set no longer splits across a page break in
either edition. Kit 4 defines what an effect size is before using 0.79,
on the slide, in the script, and on the admin one-pager.

Co-Authored-By: Claude Fable 5 <noreply@anthropic.com>
Claude-Session: https://claude.ai/code/session_019agQ42s1igQaB2X7GGat9R
</commit_message>
<xml_diff>
--- a/kits/kit01-tpt/Kit01_PresentationDeck.pptx
+++ b/kits/kit01-tpt/Kit01_PresentationDeck.pptx
@@ -4590,7 +4590,7 @@
         <p:spPr>
           <a:xfrm>
             <a:off x="566928" y="128016"/>
-            <a:ext cx="11055096" cy="274320"/>
+            <a:ext cx="7955280" cy="274320"/>
           </a:xfrm>
           <a:prstGeom prst="rect">
             <a:avLst/>
@@ -4629,7 +4629,7 @@
         <p:spPr>
           <a:xfrm>
             <a:off x="548640" y="384048"/>
-            <a:ext cx="11091672" cy="777240"/>
+            <a:ext cx="7955280" cy="777240"/>
           </a:xfrm>
           <a:prstGeom prst="rect">
             <a:avLst/>
@@ -5367,7 +5367,7 @@
         <p:spPr>
           <a:xfrm>
             <a:off x="566928" y="128016"/>
-            <a:ext cx="11055096" cy="274320"/>
+            <a:ext cx="7955280" cy="274320"/>
           </a:xfrm>
           <a:prstGeom prst="rect">
             <a:avLst/>
@@ -5406,7 +5406,7 @@
         <p:spPr>
           <a:xfrm>
             <a:off x="548640" y="384048"/>
-            <a:ext cx="11091672" cy="777240"/>
+            <a:ext cx="7955280" cy="777240"/>
           </a:xfrm>
           <a:prstGeom prst="rect">
             <a:avLst/>
@@ -6181,7 +6181,7 @@
         <p:spPr>
           <a:xfrm>
             <a:off x="566928" y="128016"/>
-            <a:ext cx="11055096" cy="274320"/>
+            <a:ext cx="7955280" cy="274320"/>
           </a:xfrm>
           <a:prstGeom prst="rect">
             <a:avLst/>
@@ -6220,7 +6220,7 @@
         <p:spPr>
           <a:xfrm>
             <a:off x="548640" y="384048"/>
-            <a:ext cx="11091672" cy="777240"/>
+            <a:ext cx="7955280" cy="777240"/>
           </a:xfrm>
           <a:prstGeom prst="rect">
             <a:avLst/>
@@ -6863,7 +6863,7 @@
         <p:spPr>
           <a:xfrm>
             <a:off x="566928" y="128016"/>
-            <a:ext cx="11055096" cy="274320"/>
+            <a:ext cx="7955280" cy="274320"/>
           </a:xfrm>
           <a:prstGeom prst="rect">
             <a:avLst/>
@@ -6902,23 +6902,23 @@
         <p:spPr>
           <a:xfrm>
             <a:off x="548640" y="384048"/>
-            <a:ext cx="11091672" cy="777240"/>
-          </a:xfrm>
-          <a:prstGeom prst="rect">
-            <a:avLst/>
-          </a:prstGeom>
-          <a:noFill/>
-          <a:ln/>
-        </p:spPr>
-        <p:txBody>
-          <a:bodyPr wrap="square" lIns="0" tIns="0" rIns="0" bIns="0" rtlCol="0" anchor="ctr"/>
-          <a:lstStyle/>
-          <a:p>
-            <a:pPr indent="0" marL="0">
-              <a:buNone/>
-            </a:pPr>
-            <a:r>
-              <a:rPr lang="en-US" sz="3200" b="1" dirty="0">
+            <a:ext cx="7955280" cy="777240"/>
+          </a:xfrm>
+          <a:prstGeom prst="rect">
+            <a:avLst/>
+          </a:prstGeom>
+          <a:noFill/>
+          <a:ln/>
+        </p:spPr>
+        <p:txBody>
+          <a:bodyPr wrap="square" lIns="0" tIns="0" rIns="0" bIns="0" rtlCol="0" anchor="ctr"/>
+          <a:lstStyle/>
+          <a:p>
+            <a:pPr indent="0" marL="0">
+              <a:buNone/>
+            </a:pPr>
+            <a:r>
+              <a:rPr lang="en-US" sz="2800" b="1" dirty="0">
                 <a:solidFill>
                   <a:srgbClr val="13293D"/>
                 </a:solidFill>
@@ -6928,7 +6928,7 @@
               </a:rPr>
               <a:t>“Public tool” vs. district-approved tool</a:t>
             </a:r>
-            <a:endParaRPr lang="en-US" sz="3200" dirty="0"/>
+            <a:endParaRPr lang="en-US" sz="2800" dirty="0"/>
           </a:p>
         </p:txBody>
       </p:sp>
@@ -7552,7 +7552,7 @@
         <p:spPr>
           <a:xfrm>
             <a:off x="566928" y="128016"/>
-            <a:ext cx="11055096" cy="274320"/>
+            <a:ext cx="7955280" cy="274320"/>
           </a:xfrm>
           <a:prstGeom prst="rect">
             <a:avLst/>
@@ -7591,7 +7591,7 @@
         <p:spPr>
           <a:xfrm>
             <a:off x="548640" y="384048"/>
-            <a:ext cx="11091672" cy="777240"/>
+            <a:ext cx="7955280" cy="777240"/>
           </a:xfrm>
           <a:prstGeom prst="rect">
             <a:avLst/>
@@ -8827,7 +8827,7 @@
         <p:spPr>
           <a:xfrm>
             <a:off x="566928" y="128016"/>
-            <a:ext cx="11055096" cy="274320"/>
+            <a:ext cx="7955280" cy="274320"/>
           </a:xfrm>
           <a:prstGeom prst="rect">
             <a:avLst/>
@@ -8866,7 +8866,7 @@
         <p:spPr>
           <a:xfrm>
             <a:off x="548640" y="384048"/>
-            <a:ext cx="11091672" cy="777240"/>
+            <a:ext cx="7955280" cy="777240"/>
           </a:xfrm>
           <a:prstGeom prst="rect">
             <a:avLst/>
@@ -9509,7 +9509,7 @@
         <p:spPr>
           <a:xfrm>
             <a:off x="566928" y="128016"/>
-            <a:ext cx="11055096" cy="274320"/>
+            <a:ext cx="7955280" cy="274320"/>
           </a:xfrm>
           <a:prstGeom prst="rect">
             <a:avLst/>
@@ -9548,23 +9548,23 @@
         <p:spPr>
           <a:xfrm>
             <a:off x="548640" y="384048"/>
-            <a:ext cx="11091672" cy="777240"/>
-          </a:xfrm>
-          <a:prstGeom prst="rect">
-            <a:avLst/>
-          </a:prstGeom>
-          <a:noFill/>
-          <a:ln/>
-        </p:spPr>
-        <p:txBody>
-          <a:bodyPr wrap="square" lIns="0" tIns="0" rIns="0" bIns="0" rtlCol="0" anchor="ctr"/>
-          <a:lstStyle/>
-          <a:p>
-            <a:pPr indent="0" marL="0">
-              <a:buNone/>
-            </a:pPr>
-            <a:r>
-              <a:rPr lang="en-US" sz="3200" b="1" dirty="0">
+            <a:ext cx="7955280" cy="777240"/>
+          </a:xfrm>
+          <a:prstGeom prst="rect">
+            <a:avLst/>
+          </a:prstGeom>
+          <a:noFill/>
+          <a:ln/>
+        </p:spPr>
+        <p:txBody>
+          <a:bodyPr wrap="square" lIns="0" tIns="0" rIns="0" bIns="0" rtlCol="0" anchor="ctr"/>
+          <a:lstStyle/>
+          <a:p>
+            <a:pPr indent="0" marL="0">
+              <a:buNone/>
+            </a:pPr>
+            <a:r>
+              <a:rPr lang="en-US" sz="2800" b="1" dirty="0">
                 <a:solidFill>
                   <a:srgbClr val="13293D"/>
                 </a:solidFill>
@@ -9574,7 +9574,7 @@
               </a:rPr>
               <a:t>De-identify like a pro: the 3 moves</a:t>
             </a:r>
-            <a:endParaRPr lang="en-US" sz="3200" dirty="0"/>
+            <a:endParaRPr lang="en-US" sz="2800" dirty="0"/>
           </a:p>
         </p:txBody>
       </p:sp>
@@ -10488,7 +10488,7 @@
         <p:spPr>
           <a:xfrm>
             <a:off x="566928" y="128016"/>
-            <a:ext cx="11055096" cy="274320"/>
+            <a:ext cx="7955280" cy="274320"/>
           </a:xfrm>
           <a:prstGeom prst="rect">
             <a:avLst/>
@@ -10527,7 +10527,7 @@
         <p:spPr>
           <a:xfrm>
             <a:off x="548640" y="384048"/>
-            <a:ext cx="11091672" cy="777240"/>
+            <a:ext cx="7955280" cy="777240"/>
           </a:xfrm>
           <a:prstGeom prst="rect">
             <a:avLst/>
@@ -11488,7 +11488,7 @@
         <p:spPr>
           <a:xfrm>
             <a:off x="566928" y="128016"/>
-            <a:ext cx="11055096" cy="274320"/>
+            <a:ext cx="7955280" cy="274320"/>
           </a:xfrm>
           <a:prstGeom prst="rect">
             <a:avLst/>
@@ -11527,7 +11527,7 @@
         <p:spPr>
           <a:xfrm>
             <a:off x="548640" y="384048"/>
-            <a:ext cx="11091672" cy="777240"/>
+            <a:ext cx="7955280" cy="777240"/>
           </a:xfrm>
           <a:prstGeom prst="rect">
             <a:avLst/>
@@ -12223,7 +12223,7 @@
         <p:spPr>
           <a:xfrm>
             <a:off x="566928" y="128016"/>
-            <a:ext cx="11055096" cy="274320"/>
+            <a:ext cx="7955280" cy="274320"/>
           </a:xfrm>
           <a:prstGeom prst="rect">
             <a:avLst/>
@@ -13004,7 +13004,7 @@
         <p:spPr>
           <a:xfrm>
             <a:off x="566928" y="128016"/>
-            <a:ext cx="11055096" cy="274320"/>
+            <a:ext cx="7955280" cy="274320"/>
           </a:xfrm>
           <a:prstGeom prst="rect">
             <a:avLst/>
@@ -14521,7 +14521,7 @@
         <p:spPr>
           <a:xfrm>
             <a:off x="566928" y="128016"/>
-            <a:ext cx="11055096" cy="274320"/>
+            <a:ext cx="7955280" cy="274320"/>
           </a:xfrm>
           <a:prstGeom prst="rect">
             <a:avLst/>
@@ -15743,7 +15743,7 @@
         <p:spPr>
           <a:xfrm>
             <a:off x="566928" y="128016"/>
-            <a:ext cx="11055096" cy="274320"/>
+            <a:ext cx="7955280" cy="274320"/>
           </a:xfrm>
           <a:prstGeom prst="rect">
             <a:avLst/>
@@ -15782,7 +15782,7 @@
         <p:spPr>
           <a:xfrm>
             <a:off x="548640" y="384048"/>
-            <a:ext cx="11091672" cy="777240"/>
+            <a:ext cx="7955280" cy="777240"/>
           </a:xfrm>
           <a:prstGeom prst="rect">
             <a:avLst/>
@@ -16341,7 +16341,7 @@
         <p:spPr>
           <a:xfrm>
             <a:off x="566928" y="128016"/>
-            <a:ext cx="11055096" cy="274320"/>
+            <a:ext cx="7955280" cy="274320"/>
           </a:xfrm>
           <a:prstGeom prst="rect">
             <a:avLst/>
@@ -16380,7 +16380,7 @@
         <p:spPr>
           <a:xfrm>
             <a:off x="548640" y="384048"/>
-            <a:ext cx="11091672" cy="777240"/>
+            <a:ext cx="7955280" cy="777240"/>
           </a:xfrm>
           <a:prstGeom prst="rect">
             <a:avLst/>
@@ -16925,7 +16925,7 @@
         <p:spPr>
           <a:xfrm>
             <a:off x="566928" y="128016"/>
-            <a:ext cx="11055096" cy="274320"/>
+            <a:ext cx="7955280" cy="274320"/>
           </a:xfrm>
           <a:prstGeom prst="rect">
             <a:avLst/>
@@ -16964,7 +16964,7 @@
         <p:spPr>
           <a:xfrm>
             <a:off x="548640" y="384048"/>
-            <a:ext cx="11091672" cy="777240"/>
+            <a:ext cx="7955280" cy="777240"/>
           </a:xfrm>
           <a:prstGeom prst="rect">
             <a:avLst/>
@@ -17712,7 +17712,7 @@
         <p:spPr>
           <a:xfrm>
             <a:off x="566928" y="128016"/>
-            <a:ext cx="11055096" cy="274320"/>
+            <a:ext cx="7955280" cy="274320"/>
           </a:xfrm>
           <a:prstGeom prst="rect">
             <a:avLst/>
@@ -17751,7 +17751,7 @@
         <p:spPr>
           <a:xfrm>
             <a:off x="548640" y="384048"/>
-            <a:ext cx="11091672" cy="777240"/>
+            <a:ext cx="7955280" cy="777240"/>
           </a:xfrm>
           <a:prstGeom prst="rect">
             <a:avLst/>
@@ -18296,7 +18296,7 @@
         <p:spPr>
           <a:xfrm>
             <a:off x="566928" y="128016"/>
-            <a:ext cx="11055096" cy="274320"/>
+            <a:ext cx="7955280" cy="274320"/>
           </a:xfrm>
           <a:prstGeom prst="rect">
             <a:avLst/>
@@ -19077,7 +19077,7 @@
         <p:spPr>
           <a:xfrm>
             <a:off x="566928" y="128016"/>
-            <a:ext cx="11055096" cy="274320"/>
+            <a:ext cx="7955280" cy="274320"/>
           </a:xfrm>
           <a:prstGeom prst="rect">
             <a:avLst/>
@@ -19116,23 +19116,23 @@
         <p:spPr>
           <a:xfrm>
             <a:off x="548640" y="384048"/>
-            <a:ext cx="11091672" cy="777240"/>
-          </a:xfrm>
-          <a:prstGeom prst="rect">
-            <a:avLst/>
-          </a:prstGeom>
-          <a:noFill/>
-          <a:ln/>
-        </p:spPr>
-        <p:txBody>
-          <a:bodyPr wrap="square" lIns="0" tIns="0" rIns="0" bIns="0" rtlCol="0" anchor="ctr"/>
-          <a:lstStyle/>
-          <a:p>
-            <a:pPr indent="0" marL="0">
-              <a:buNone/>
-            </a:pPr>
-            <a:r>
-              <a:rPr lang="en-US" sz="3200" b="1" dirty="0">
+            <a:ext cx="7955280" cy="777240"/>
+          </a:xfrm>
+          <a:prstGeom prst="rect">
+            <a:avLst/>
+          </a:prstGeom>
+          <a:noFill/>
+          <a:ln/>
+        </p:spPr>
+        <p:txBody>
+          <a:bodyPr wrap="square" lIns="0" tIns="0" rIns="0" bIns="0" rtlCol="0" anchor="ctr"/>
+          <a:lstStyle/>
+          <a:p>
+            <a:pPr indent="0" marL="0">
+              <a:buNone/>
+            </a:pPr>
+            <a:r>
+              <a:rPr lang="en-US" sz="2800" b="1" dirty="0">
                 <a:solidFill>
                   <a:srgbClr val="13293D"/>
                 </a:solidFill>
@@ -19142,7 +19142,7 @@
               </a:rPr>
               <a:t>Your first 48 hours: three small things</a:t>
             </a:r>
-            <a:endParaRPr lang="en-US" sz="3200" dirty="0"/>
+            <a:endParaRPr lang="en-US" sz="2800" dirty="0"/>
           </a:p>
         </p:txBody>
       </p:sp>
@@ -19981,7 +19981,7 @@
         <p:spPr>
           <a:xfrm>
             <a:off x="566928" y="128016"/>
-            <a:ext cx="11055096" cy="274320"/>
+            <a:ext cx="7955280" cy="274320"/>
           </a:xfrm>
           <a:prstGeom prst="rect">
             <a:avLst/>
@@ -20020,7 +20020,7 @@
         <p:spPr>
           <a:xfrm>
             <a:off x="548640" y="384048"/>
-            <a:ext cx="11091672" cy="777240"/>
+            <a:ext cx="7955280" cy="777240"/>
           </a:xfrm>
           <a:prstGeom prst="rect">
             <a:avLst/>
@@ -21022,7 +21022,7 @@
         <p:spPr>
           <a:xfrm>
             <a:off x="566928" y="128016"/>
-            <a:ext cx="11055096" cy="274320"/>
+            <a:ext cx="7955280" cy="274320"/>
           </a:xfrm>
           <a:prstGeom prst="rect">
             <a:avLst/>
@@ -22311,7 +22311,7 @@
         <p:spPr>
           <a:xfrm>
             <a:off x="566928" y="128016"/>
-            <a:ext cx="11055096" cy="274320"/>
+            <a:ext cx="7955280" cy="274320"/>
           </a:xfrm>
           <a:prstGeom prst="rect">
             <a:avLst/>
@@ -22350,7 +22350,7 @@
         <p:spPr>
           <a:xfrm>
             <a:off x="548640" y="384048"/>
-            <a:ext cx="11091672" cy="777240"/>
+            <a:ext cx="7955280" cy="777240"/>
           </a:xfrm>
           <a:prstGeom prst="rect">
             <a:avLst/>
@@ -23395,7 +23395,7 @@
         <p:spPr>
           <a:xfrm>
             <a:off x="566928" y="128016"/>
-            <a:ext cx="11055096" cy="274320"/>
+            <a:ext cx="7955280" cy="274320"/>
           </a:xfrm>
           <a:prstGeom prst="rect">
             <a:avLst/>
@@ -23434,7 +23434,7 @@
         <p:spPr>
           <a:xfrm>
             <a:off x="548640" y="384048"/>
-            <a:ext cx="11091672" cy="777240"/>
+            <a:ext cx="7955280" cy="777240"/>
           </a:xfrm>
           <a:prstGeom prst="rect">
             <a:avLst/>
@@ -23993,7 +23993,7 @@
         <p:spPr>
           <a:xfrm>
             <a:off x="566928" y="128016"/>
-            <a:ext cx="11055096" cy="274320"/>
+            <a:ext cx="7955280" cy="274320"/>
           </a:xfrm>
           <a:prstGeom prst="rect">
             <a:avLst/>
@@ -24032,7 +24032,7 @@
         <p:spPr>
           <a:xfrm>
             <a:off x="548640" y="384048"/>
-            <a:ext cx="11091672" cy="777240"/>
+            <a:ext cx="7955280" cy="777240"/>
           </a:xfrm>
           <a:prstGeom prst="rect">
             <a:avLst/>
@@ -24675,7 +24675,7 @@
         <p:spPr>
           <a:xfrm>
             <a:off x="566928" y="128016"/>
-            <a:ext cx="11055096" cy="274320"/>
+            <a:ext cx="7955280" cy="274320"/>
           </a:xfrm>
           <a:prstGeom prst="rect">
             <a:avLst/>
@@ -25232,7 +25232,7 @@
         <p:spPr>
           <a:xfrm>
             <a:off x="566928" y="128016"/>
-            <a:ext cx="11055096" cy="274320"/>
+            <a:ext cx="7955280" cy="274320"/>
           </a:xfrm>
           <a:prstGeom prst="rect">
             <a:avLst/>
@@ -25271,7 +25271,7 @@
         <p:spPr>
           <a:xfrm>
             <a:off x="548640" y="384048"/>
-            <a:ext cx="11091672" cy="777240"/>
+            <a:ext cx="7955280" cy="777240"/>
           </a:xfrm>
           <a:prstGeom prst="rect">
             <a:avLst/>
@@ -26124,7 +26124,7 @@
         <p:spPr>
           <a:xfrm>
             <a:off x="566928" y="128016"/>
-            <a:ext cx="11055096" cy="274320"/>
+            <a:ext cx="7955280" cy="274320"/>
           </a:xfrm>
           <a:prstGeom prst="rect">
             <a:avLst/>
@@ -26163,7 +26163,7 @@
         <p:spPr>
           <a:xfrm>
             <a:off x="548640" y="384048"/>
-            <a:ext cx="11091672" cy="777240"/>
+            <a:ext cx="7955280" cy="777240"/>
           </a:xfrm>
           <a:prstGeom prst="rect">
             <a:avLst/>

</xml_diff>

<commit_message>
Sharpen the overlap checker; fix long titles crowding the kicker
The checker compared text blocks, whose boxes carry paragraph padding, so
stacked frames inside one card read as collisions while rendering fine.
That noise hid real hits. It now compares rendered lines, whose boxes hug
the glyphs. Validated against a known-bad build: line level finds all 16
real collisions there and none of the stacked-card false positives.

With the sharper test, four kits showed a long title centering upward
into its kicker. Titles that wrap now step down a size, start lower, and
top-align, so they clear the kicker whatever their length. Applied to all
ten decks, which also closes the chip collisions still open in Kits 5-8.

Co-Authored-By: Claude Fable 5 <noreply@anthropic.com>
Claude-Session: https://claude.ai/code/session_019agQ42s1igQaB2X7GGat9R
</commit_message>
<xml_diff>
--- a/kits/kit01-tpt/Kit01_PresentationDeck.pptx
+++ b/kits/kit01-tpt/Kit01_PresentationDeck.pptx
@@ -7257,17 +7257,17 @@
         </p:nvSpPr>
         <p:spPr>
           <a:xfrm>
-            <a:off x="548640" y="384048"/>
-            <a:ext cx="7955280" cy="777240"/>
-          </a:xfrm>
-          <a:prstGeom prst="rect">
-            <a:avLst/>
-          </a:prstGeom>
-          <a:noFill/>
-          <a:ln/>
-        </p:spPr>
-        <p:txBody>
-          <a:bodyPr wrap="square" lIns="0" tIns="0" rIns="0" bIns="0" rtlCol="0" anchor="ctr"/>
+            <a:off x="548640" y="457200"/>
+            <a:ext cx="7955280" cy="914400"/>
+          </a:xfrm>
+          <a:prstGeom prst="rect">
+            <a:avLst/>
+          </a:prstGeom>
+          <a:noFill/>
+          <a:ln/>
+        </p:spPr>
+        <p:txBody>
+          <a:bodyPr wrap="square" lIns="0" tIns="0" rIns="0" bIns="0" rtlCol="0" anchor="t"/>
           <a:lstStyle/>
           <a:p>
             <a:pPr indent="0" marL="0">
@@ -7946,24 +7946,24 @@
         </p:nvSpPr>
         <p:spPr>
           <a:xfrm>
-            <a:off x="548640" y="384048"/>
-            <a:ext cx="7955280" cy="777240"/>
-          </a:xfrm>
-          <a:prstGeom prst="rect">
-            <a:avLst/>
-          </a:prstGeom>
-          <a:noFill/>
-          <a:ln/>
-        </p:spPr>
-        <p:txBody>
-          <a:bodyPr wrap="square" lIns="0" tIns="0" rIns="0" bIns="0" rtlCol="0" anchor="ctr"/>
-          <a:lstStyle/>
-          <a:p>
-            <a:pPr indent="0" marL="0">
-              <a:buNone/>
-            </a:pPr>
-            <a:r>
-              <a:rPr lang="en-US" sz="3200" b="1" dirty="0">
+            <a:off x="548640" y="457200"/>
+            <a:ext cx="7955280" cy="914400"/>
+          </a:xfrm>
+          <a:prstGeom prst="rect">
+            <a:avLst/>
+          </a:prstGeom>
+          <a:noFill/>
+          <a:ln/>
+        </p:spPr>
+        <p:txBody>
+          <a:bodyPr wrap="square" lIns="0" tIns="0" rIns="0" bIns="0" rtlCol="0" anchor="t"/>
+          <a:lstStyle/>
+          <a:p>
+            <a:pPr indent="0" marL="0">
+              <a:buNone/>
+            </a:pPr>
+            <a:r>
+              <a:rPr lang="en-US" sz="2800" b="1" dirty="0">
                 <a:solidFill>
                   <a:srgbClr val="13293D"/>
                 </a:solidFill>
@@ -7973,7 +7973,7 @@
               </a:rPr>
               <a:t>The rule barely costs you anything</a:t>
             </a:r>
-            <a:endParaRPr lang="en-US" sz="3200" dirty="0"/>
+            <a:endParaRPr lang="en-US" sz="2800" dirty="0"/>
           </a:p>
         </p:txBody>
       </p:sp>
@@ -9903,17 +9903,17 @@
         </p:nvSpPr>
         <p:spPr>
           <a:xfrm>
-            <a:off x="548640" y="384048"/>
-            <a:ext cx="7955280" cy="777240"/>
-          </a:xfrm>
-          <a:prstGeom prst="rect">
-            <a:avLst/>
-          </a:prstGeom>
-          <a:noFill/>
-          <a:ln/>
-        </p:spPr>
-        <p:txBody>
-          <a:bodyPr wrap="square" lIns="0" tIns="0" rIns="0" bIns="0" rtlCol="0" anchor="ctr"/>
+            <a:off x="548640" y="457200"/>
+            <a:ext cx="7955280" cy="914400"/>
+          </a:xfrm>
+          <a:prstGeom prst="rect">
+            <a:avLst/>
+          </a:prstGeom>
+          <a:noFill/>
+          <a:ln/>
+        </p:spPr>
+        <p:txBody>
+          <a:bodyPr wrap="square" lIns="0" tIns="0" rIns="0" bIns="0" rtlCol="0" anchor="t"/>
           <a:lstStyle/>
           <a:p>
             <a:pPr indent="0" marL="0">
@@ -13398,24 +13398,24 @@
         </p:nvSpPr>
         <p:spPr>
           <a:xfrm>
-            <a:off x="548640" y="384048"/>
-            <a:ext cx="7955280" cy="777240"/>
-          </a:xfrm>
-          <a:prstGeom prst="rect">
-            <a:avLst/>
-          </a:prstGeom>
-          <a:noFill/>
-          <a:ln/>
-        </p:spPr>
-        <p:txBody>
-          <a:bodyPr wrap="square" lIns="0" tIns="0" rIns="0" bIns="0" rtlCol="0" anchor="ctr"/>
-          <a:lstStyle/>
-          <a:p>
-            <a:pPr indent="0" marL="0">
-              <a:buNone/>
-            </a:pPr>
-            <a:r>
-              <a:rPr lang="en-US" sz="3200" b="1" dirty="0">
+            <a:off x="548640" y="457200"/>
+            <a:ext cx="7955280" cy="914400"/>
+          </a:xfrm>
+          <a:prstGeom prst="rect">
+            <a:avLst/>
+          </a:prstGeom>
+          <a:noFill/>
+          <a:ln/>
+        </p:spPr>
+        <p:txBody>
+          <a:bodyPr wrap="square" lIns="0" tIns="0" rIns="0" bIns="0" rtlCol="0" anchor="t"/>
+          <a:lstStyle/>
+          <a:p>
+            <a:pPr indent="0" marL="0">
+              <a:buNone/>
+            </a:pPr>
+            <a:r>
+              <a:rPr lang="en-US" sz="2800" b="1" dirty="0">
                 <a:solidFill>
                   <a:srgbClr val="13293D"/>
                 </a:solidFill>
@@ -13425,7 +13425,7 @@
               </a:rPr>
               <a:t>Your first useful prompt: pick one</a:t>
             </a:r>
-            <a:endParaRPr lang="en-US" sz="3200" dirty="0"/>
+            <a:endParaRPr lang="en-US" sz="2800" dirty="0"/>
           </a:p>
         </p:txBody>
       </p:sp>
@@ -19377,24 +19377,24 @@
         </p:nvSpPr>
         <p:spPr>
           <a:xfrm>
-            <a:off x="548640" y="384048"/>
-            <a:ext cx="7955280" cy="777240"/>
-          </a:xfrm>
-          <a:prstGeom prst="rect">
-            <a:avLst/>
-          </a:prstGeom>
-          <a:noFill/>
-          <a:ln/>
-        </p:spPr>
-        <p:txBody>
-          <a:bodyPr wrap="square" lIns="0" tIns="0" rIns="0" bIns="0" rtlCol="0" anchor="ctr"/>
-          <a:lstStyle/>
-          <a:p>
-            <a:pPr indent="0" marL="0">
-              <a:buNone/>
-            </a:pPr>
-            <a:r>
-              <a:rPr lang="en-US" sz="3200" b="1" dirty="0">
+            <a:off x="548640" y="457200"/>
+            <a:ext cx="7955280" cy="914400"/>
+          </a:xfrm>
+          <a:prstGeom prst="rect">
+            <a:avLst/>
+          </a:prstGeom>
+          <a:noFill/>
+          <a:ln/>
+        </p:spPr>
+        <p:txBody>
+          <a:bodyPr wrap="square" lIns="0" tIns="0" rIns="0" bIns="0" rtlCol="0" anchor="t"/>
+          <a:lstStyle/>
+          <a:p>
+            <a:pPr indent="0" marL="0">
+              <a:buNone/>
+            </a:pPr>
+            <a:r>
+              <a:rPr lang="en-US" sz="2800" b="1" dirty="0">
                 <a:solidFill>
                   <a:srgbClr val="13293D"/>
                 </a:solidFill>
@@ -19404,7 +19404,7 @@
               </a:rPr>
               <a:t>Honest limits: the risks are real</a:t>
             </a:r>
-            <a:endParaRPr lang="en-US" sz="3200" dirty="0"/>
+            <a:endParaRPr lang="en-US" sz="2800" dirty="0"/>
           </a:p>
         </p:txBody>
       </p:sp>
@@ -20164,17 +20164,17 @@
         </p:nvSpPr>
         <p:spPr>
           <a:xfrm>
-            <a:off x="548640" y="384048"/>
-            <a:ext cx="7955280" cy="777240"/>
-          </a:xfrm>
-          <a:prstGeom prst="rect">
-            <a:avLst/>
-          </a:prstGeom>
-          <a:noFill/>
-          <a:ln/>
-        </p:spPr>
-        <p:txBody>
-          <a:bodyPr wrap="square" lIns="0" tIns="0" rIns="0" bIns="0" rtlCol="0" anchor="ctr"/>
+            <a:off x="548640" y="457200"/>
+            <a:ext cx="7955280" cy="914400"/>
+          </a:xfrm>
+          <a:prstGeom prst="rect">
+            <a:avLst/>
+          </a:prstGeom>
+          <a:noFill/>
+          <a:ln/>
+        </p:spPr>
+        <p:txBody>
+          <a:bodyPr wrap="square" lIns="0" tIns="0" rIns="0" bIns="0" rtlCol="0" anchor="t"/>
           <a:lstStyle/>
           <a:p>
             <a:pPr indent="0" marL="0">
@@ -22429,17 +22429,17 @@
         </p:nvSpPr>
         <p:spPr>
           <a:xfrm>
-            <a:off x="548640" y="384048"/>
-            <a:ext cx="7955280" cy="777240"/>
-          </a:xfrm>
-          <a:prstGeom prst="rect">
-            <a:avLst/>
-          </a:prstGeom>
-          <a:noFill/>
-          <a:ln/>
-        </p:spPr>
-        <p:txBody>
-          <a:bodyPr wrap="square" lIns="0" tIns="0" rIns="0" bIns="0" rtlCol="0" anchor="ctr"/>
+            <a:off x="548640" y="457200"/>
+            <a:ext cx="7955280" cy="914400"/>
+          </a:xfrm>
+          <a:prstGeom prst="rect">
+            <a:avLst/>
+          </a:prstGeom>
+          <a:noFill/>
+          <a:ln/>
+        </p:spPr>
+        <p:txBody>
+          <a:bodyPr wrap="square" lIns="0" tIns="0" rIns="0" bIns="0" rtlCol="0" anchor="t"/>
           <a:lstStyle/>
           <a:p>
             <a:pPr indent="0" marL="0">
@@ -28593,24 +28593,24 @@
         </p:nvSpPr>
         <p:spPr>
           <a:xfrm>
-            <a:off x="548640" y="384048"/>
-            <a:ext cx="7955280" cy="777240"/>
-          </a:xfrm>
-          <a:prstGeom prst="rect">
-            <a:avLst/>
-          </a:prstGeom>
-          <a:noFill/>
-          <a:ln/>
-        </p:spPr>
-        <p:txBody>
-          <a:bodyPr wrap="square" lIns="0" tIns="0" rIns="0" bIns="0" rtlCol="0" anchor="ctr"/>
-          <a:lstStyle/>
-          <a:p>
-            <a:pPr indent="0" marL="0">
-              <a:buNone/>
-            </a:pPr>
-            <a:r>
-              <a:rPr lang="en-US" sz="3200" b="1" dirty="0">
+            <a:off x="548640" y="457200"/>
+            <a:ext cx="7955280" cy="914400"/>
+          </a:xfrm>
+          <a:prstGeom prst="rect">
+            <a:avLst/>
+          </a:prstGeom>
+          <a:noFill/>
+          <a:ln/>
+        </p:spPr>
+        <p:txBody>
+          <a:bodyPr wrap="square" lIns="0" tIns="0" rIns="0" bIns="0" rtlCol="0" anchor="t"/>
+          <a:lstStyle/>
+          <a:p>
+            <a:pPr indent="0" marL="0">
+              <a:buNone/>
+            </a:pPr>
+            <a:r>
+              <a:rPr lang="en-US" sz="2800" b="1" dirty="0">
                 <a:solidFill>
                   <a:srgbClr val="13293D"/>
                 </a:solidFill>
@@ -28620,7 +28620,7 @@
               </a:rPr>
               <a:t>What it can’t do, at any price</a:t>
             </a:r>
-            <a:endParaRPr lang="en-US" sz="3200" dirty="0"/>
+            <a:endParaRPr lang="en-US" sz="2800" dirty="0"/>
           </a:p>
         </p:txBody>
       </p:sp>

</xml_diff>

<commit_message>
Launch package: repoint every product at TpT, add covers and upload sheet
The owner is TpT-only with no website, so every pointer to
ai-readyschool.com or a membership was a dead end inside a product
someone paid for. All of them now point at the TpT store instead:
the license line offers discounted additional licenses, the certificate
and progress-tracking language is gone, and De-ID Drills sends readers
to the store rather than a site.

Adds tpt/make_covers.js and the five missing free-resource covers so all
eight launch products look like one set, and tpt/UPLOAD_TODAY.md with
paste-ready title, description, tags, price and file for each.

The pricing call that matters: additional licenses at $10 rather than
TpT's 10% default. A staff of twenty at $21.60 each is a number no
principal approves; at $10 it is the whole business.

Co-Authored-By: Claude Fable 5 <noreply@anthropic.com>
Claude-Session: https://claude.ai/code/session_019agQ42s1igQaB2X7GGat9R
</commit_message>
<xml_diff>
--- a/kits/kit01-tpt/Kit01_PresentationDeck.pptx
+++ b/kits/kit01-tpt/Kit01_PresentationDeck.pptx
@@ -2823,7 +2823,7 @@
           <a:p>
             <a:r>
               <a:rPr lang="en-US" dirty="0"/>
-              <a:t>Next up is Kit 2, Prompting Basics: consistently useful results instead of occasionally lucky ones. Progress tracking and the certificate run through an AI-Ready School membership (ai-readyschool.com). Certificate language is exactly "Certificate of Completion"; check with your district whether it qualifies for local credit.</a:t>
+              <a:t>Next up is Kit 2, Prompting Basics: consistently useful results instead of occasionally lucky ones. The rest of the series is in our TpT store whenever this staff is ready. The exit ticket doubles as documentation of this hour; check with your district whether it qualifies for local credit.</a:t>
             </a:r>
             <a:endParaRPr lang="en-US" dirty="0"/>
           </a:p>
@@ -23952,7 +23952,7 @@
                 <a:ea typeface="Inter" pitchFamily="34" charset="-122"/>
                 <a:cs typeface="Inter" pitchFamily="34" charset="-120"/>
               </a:rPr>
-              <a:t>Finish all eight → the AI-Ready Educator Certificate of Completion (school membership).</a:t>
+              <a:t>All eight sessions are available in our TpT store, individually or bundled.</a:t>
             </a:r>
             <a:pPr indent="0" marL="0">
               <a:buNone/>

</xml_diff>